<commit_message>
docs: streamline assignment submission
</commit_message>
<xml_diff>
--- a/docs/presentation/us-market-pipeline-assignment.pptx
+++ b/docs/presentation/us-market-pipeline-assignment.pptx
@@ -2,19 +2,19 @@
 <file path=ppt/presentation.xml><?xml version="1.0" encoding="utf-8"?>
 <p:presentation xmlns:p="http://schemas.openxmlformats.org/presentationml/2006/main">
   <p:sldMasterIdLst>
-    <p:sldMasterId xmlns:r="http://schemas.openxmlformats.org/officeDocument/2006/relationships" id="2147483648" r:id="R58f50de02e08423b"/>
+    <p:sldMasterId xmlns:r="http://schemas.openxmlformats.org/officeDocument/2006/relationships" id="2147483648" r:id="Re4981895e29f406e"/>
   </p:sldMasterIdLst>
   <p:notesMasterIdLst>
-    <p:notesMasterId xmlns:r="http://schemas.openxmlformats.org/officeDocument/2006/relationships" r:id="R9f24ecf2d4ef4165"/>
+    <p:notesMasterId xmlns:r="http://schemas.openxmlformats.org/officeDocument/2006/relationships" r:id="R7bbe9e3e7b624cb7"/>
   </p:notesMasterIdLst>
   <p:sldIdLst>
-    <p:sldId xmlns:r="http://schemas.openxmlformats.org/officeDocument/2006/relationships" id="256" r:id="R69f6f4d386974a39"/>
-    <p:sldId xmlns:r="http://schemas.openxmlformats.org/officeDocument/2006/relationships" id="257" r:id="R683948e5e5534871"/>
-    <p:sldId xmlns:r="http://schemas.openxmlformats.org/officeDocument/2006/relationships" id="258" r:id="R5ac5c18b32004f0c"/>
-    <p:sldId xmlns:r="http://schemas.openxmlformats.org/officeDocument/2006/relationships" id="259" r:id="R987ed95ef6bf4bb4"/>
-    <p:sldId xmlns:r="http://schemas.openxmlformats.org/officeDocument/2006/relationships" id="260" r:id="R0b6c52b8ca2945f5"/>
-    <p:sldId xmlns:r="http://schemas.openxmlformats.org/officeDocument/2006/relationships" id="261" r:id="Rad26d99a2d4e46a5"/>
-    <p:sldId xmlns:r="http://schemas.openxmlformats.org/officeDocument/2006/relationships" id="262" r:id="R17185f8bf81f4046"/>
+    <p:sldId xmlns:r="http://schemas.openxmlformats.org/officeDocument/2006/relationships" id="256" r:id="R73dcc721ee4240ec"/>
+    <p:sldId xmlns:r="http://schemas.openxmlformats.org/officeDocument/2006/relationships" id="257" r:id="R453386b0dfb14635"/>
+    <p:sldId xmlns:r="http://schemas.openxmlformats.org/officeDocument/2006/relationships" id="258" r:id="R2934d8a7ae834767"/>
+    <p:sldId xmlns:r="http://schemas.openxmlformats.org/officeDocument/2006/relationships" id="259" r:id="R705ef5b1b98f4c12"/>
+    <p:sldId xmlns:r="http://schemas.openxmlformats.org/officeDocument/2006/relationships" id="260" r:id="Rbc7edaa061254213"/>
+    <p:sldId xmlns:r="http://schemas.openxmlformats.org/officeDocument/2006/relationships" id="261" r:id="Rcfdf33eb27974383"/>
+    <p:sldId xmlns:r="http://schemas.openxmlformats.org/officeDocument/2006/relationships" id="262" r:id="Rf878ad8d5e604a5a"/>
   </p:sldIdLst>
   <p:sldSz cx="12192000" cy="6858000"/>
   <p:notesSz cx="6858000" cy="9144000"/>
@@ -658,7 +658,7 @@
           </a:p>
           <a:p xmlns:a="http://schemas.openxmlformats.org/drawingml/2006/main">
             <a:r>
-              <a:t>- /Users/hanjeonghyun/dev/2026/for_my_stock/docs/architecture.png</a:t>
+              <a:t>- /Users/hanjeonghyun/dev/2026/for_my_stock/docs/diagrams/pipeline-architecture.png</a:t>
             </a:r>
           </a:p>
           <a:p xmlns:a="http://schemas.openxmlformats.org/drawingml/2006/main">
@@ -1126,7 +1126,7 @@
   </p:cSld>
   <p:clrMap bg1="lt1" tx1="dk1" bg2="lt2" tx2="dk2" accent1="accent1" accent2="accent2" accent3="accent3" accent4="accent4" accent5="accent5" accent6="accent6" hlink="hlink" folHlink="folHlink"/>
   <p:sldLayoutIdLst>
-    <p:sldLayoutId xmlns:r="http://schemas.openxmlformats.org/officeDocument/2006/relationships" id="2147483649" r:id="R824aa640a7a64e27"/>
+    <p:sldLayoutId xmlns:r="http://schemas.openxmlformats.org/officeDocument/2006/relationships" id="2147483649" r:id="Rc718fb8ff0c44ea5"/>
   </p:sldLayoutIdLst>
   <p:txStyles>
     <p:titleStyle>
@@ -1677,7 +1677,7 @@
           <p:cNvPr id="11" name="">
             <a:extLst xmlns:a="http://schemas.openxmlformats.org/drawingml/2006/main">
               <a:ext uri="{FF2B5EF4-FFF2-40B4-BE49-F238E27FC236}">
-                <a16:creationId xmlns:a16="http://schemas.microsoft.com/office/drawing/2014/main" id="{C291FCFA-0899-4C3C-BFD1-F419BBC975C1}"/>
+                <a16:creationId xmlns:a16="http://schemas.microsoft.com/office/drawing/2014/main" id="{09D7C98B-16B2-40E3-BD6D-DEE211C47725}"/>
               </a:ext>
             </a:extLst>
           </p:cNvPr>
@@ -1735,7 +1735,7 @@
           <p:cNvPr id="2" name="cover-title">
             <a:extLst xmlns:a="http://schemas.openxmlformats.org/drawingml/2006/main">
               <a:ext uri="{FF2B5EF4-FFF2-40B4-BE49-F238E27FC236}">
-                <a16:creationId xmlns:a16="http://schemas.microsoft.com/office/drawing/2014/main" id="{F1259972-8AAC-46CA-B51B-195767902789}"/>
+                <a16:creationId xmlns:a16="http://schemas.microsoft.com/office/drawing/2014/main" id="{89C178F0-DC57-461A-A686-4E300C58A818}"/>
               </a:ext>
             </a:extLst>
           </p:cNvPr>
@@ -1816,7 +1816,7 @@
           <p:cNvPr id="3" name="">
             <a:extLst xmlns:a="http://schemas.openxmlformats.org/drawingml/2006/main">
               <a:ext uri="{FF2B5EF4-FFF2-40B4-BE49-F238E27FC236}">
-                <a16:creationId xmlns:a16="http://schemas.microsoft.com/office/drawing/2014/main" id="{F7C5F86F-7327-4929-837A-9AE3C40D7D48}"/>
+                <a16:creationId xmlns:a16="http://schemas.microsoft.com/office/drawing/2014/main" id="{29C9C91A-D567-4404-B300-DB5CF72F4FB9}"/>
               </a:ext>
             </a:extLst>
           </p:cNvPr>
@@ -1874,7 +1874,7 @@
           <p:cNvPr id="4" name="">
             <a:extLst xmlns:a="http://schemas.openxmlformats.org/drawingml/2006/main">
               <a:ext uri="{FF2B5EF4-FFF2-40B4-BE49-F238E27FC236}">
-                <a16:creationId xmlns:a16="http://schemas.microsoft.com/office/drawing/2014/main" id="{0E71B73A-8963-427D-AC2E-338ACF1D290A}"/>
+                <a16:creationId xmlns:a16="http://schemas.microsoft.com/office/drawing/2014/main" id="{CA237F0A-306C-4CAE-B37E-0CF5FA67968B}"/>
               </a:ext>
             </a:extLst>
           </p:cNvPr>
@@ -1932,7 +1932,7 @@
           <p:cNvPr id="5" name="">
             <a:extLst xmlns:a="http://schemas.openxmlformats.org/drawingml/2006/main">
               <a:ext uri="{FF2B5EF4-FFF2-40B4-BE49-F238E27FC236}">
-                <a16:creationId xmlns:a16="http://schemas.microsoft.com/office/drawing/2014/main" id="{39A95336-DCEC-4FCB-A840-1EA08D6C3FCB}"/>
+                <a16:creationId xmlns:a16="http://schemas.microsoft.com/office/drawing/2014/main" id="{F9E6FE64-9909-4FD2-8171-15956A87B112}"/>
               </a:ext>
             </a:extLst>
           </p:cNvPr>
@@ -1990,7 +1990,7 @@
           <p:cNvPr id="6" name="">
             <a:extLst xmlns:a="http://schemas.openxmlformats.org/drawingml/2006/main">
               <a:ext uri="{FF2B5EF4-FFF2-40B4-BE49-F238E27FC236}">
-                <a16:creationId xmlns:a16="http://schemas.microsoft.com/office/drawing/2014/main" id="{37862927-DA34-48CB-BA5E-8C690166335D}"/>
+                <a16:creationId xmlns:a16="http://schemas.microsoft.com/office/drawing/2014/main" id="{F0D10E54-B3DF-486E-AE2E-5E48F5F0DC45}"/>
               </a:ext>
             </a:extLst>
           </p:cNvPr>
@@ -2027,7 +2027,7 @@
           <p:nvPr/>
         </p:nvPicPr>
         <p:blipFill>
-          <a:blip xmlns:r="http://schemas.openxmlformats.org/officeDocument/2006/relationships" xmlns:a="http://schemas.openxmlformats.org/drawingml/2006/main" r:embed="Rde25345ae27347da"/>
+          <a:blip xmlns:r="http://schemas.openxmlformats.org/officeDocument/2006/relationships" xmlns:a="http://schemas.openxmlformats.org/drawingml/2006/main" r:embed="R7dc7f43128454b98"/>
           <a:stretch xmlns:a="http://schemas.openxmlformats.org/drawingml/2006/main"/>
         </p:blipFill>
         <p:spPr>
@@ -2045,7 +2045,7 @@
           <p:cNvPr id="8" name="">
             <a:extLst xmlns:a="http://schemas.openxmlformats.org/drawingml/2006/main">
               <a:ext uri="{FF2B5EF4-FFF2-40B4-BE49-F238E27FC236}">
-                <a16:creationId xmlns:a16="http://schemas.microsoft.com/office/drawing/2014/main" id="{7AE16408-02FC-47B5-9D40-37D9FB62E9FA}"/>
+                <a16:creationId xmlns:a16="http://schemas.microsoft.com/office/drawing/2014/main" id="{84B8B95B-8DFB-4369-A20D-850DB25752C8}"/>
               </a:ext>
             </a:extLst>
           </p:cNvPr>
@@ -2103,7 +2103,7 @@
           <p:cNvPr id="9" name="">
             <a:extLst xmlns:a="http://schemas.openxmlformats.org/drawingml/2006/main">
               <a:ext uri="{FF2B5EF4-FFF2-40B4-BE49-F238E27FC236}">
-                <a16:creationId xmlns:a16="http://schemas.microsoft.com/office/drawing/2014/main" id="{CE547CDB-E0EF-4682-8F2C-F716B5FD6C58}"/>
+                <a16:creationId xmlns:a16="http://schemas.microsoft.com/office/drawing/2014/main" id="{DF7B22CE-164C-4FB7-941E-33FD6B32FE44}"/>
               </a:ext>
             </a:extLst>
           </p:cNvPr>
@@ -2161,7 +2161,7 @@
           <p:cNvPr id="10" name="">
             <a:extLst xmlns:a="http://schemas.openxmlformats.org/drawingml/2006/main">
               <a:ext uri="{FF2B5EF4-FFF2-40B4-BE49-F238E27FC236}">
-                <a16:creationId xmlns:a16="http://schemas.microsoft.com/office/drawing/2014/main" id="{B78537C8-6165-48F4-BD79-2D7F378319F3}"/>
+                <a16:creationId xmlns:a16="http://schemas.microsoft.com/office/drawing/2014/main" id="{ACA709D5-AEB1-40AA-97EB-B42AAF3A5C05}"/>
               </a:ext>
             </a:extLst>
           </p:cNvPr>
@@ -2217,7 +2217,7 @@
     </p:spTree>
     <p:extLst>
       <p:ext uri="{BB962C8B-B14F-4D97-AF65-F5344CB8AC3E}">
-        <p14:creationId xmlns:p14="http://schemas.microsoft.com/office/powerpoint/2010/main" val="2079532639"/>
+        <p14:creationId xmlns:p14="http://schemas.microsoft.com/office/powerpoint/2010/main" val="784504022"/>
       </p:ext>
     </p:extLst>
   </p:cSld>
@@ -2248,7 +2248,7 @@
           <p:cNvPr id="10" name="eyebrow-2">
             <a:extLst xmlns:a="http://schemas.openxmlformats.org/drawingml/2006/main">
               <a:ext uri="{FF2B5EF4-FFF2-40B4-BE49-F238E27FC236}">
-                <a16:creationId xmlns:a16="http://schemas.microsoft.com/office/drawing/2014/main" id="{25DAE7AF-B165-4FC0-95BE-49F1327E430C}"/>
+                <a16:creationId xmlns:a16="http://schemas.microsoft.com/office/drawing/2014/main" id="{4CC2D71C-2C37-4AF4-AC80-E699ADAF771C}"/>
               </a:ext>
             </a:extLst>
           </p:cNvPr>
@@ -2306,7 +2306,7 @@
           <p:cNvPr id="2" name="title-2">
             <a:extLst xmlns:a="http://schemas.openxmlformats.org/drawingml/2006/main">
               <a:ext uri="{FF2B5EF4-FFF2-40B4-BE49-F238E27FC236}">
-                <a16:creationId xmlns:a16="http://schemas.microsoft.com/office/drawing/2014/main" id="{423366E5-C528-4907-83DF-AE1C9507BF65}"/>
+                <a16:creationId xmlns:a16="http://schemas.microsoft.com/office/drawing/2014/main" id="{9FC9209F-2C5B-47A4-8A75-55F6D4D7F2D6}"/>
               </a:ext>
             </a:extLst>
           </p:cNvPr>
@@ -2364,7 +2364,7 @@
           <p:cNvPr id="3" name="">
             <a:extLst xmlns:a="http://schemas.openxmlformats.org/drawingml/2006/main">
               <a:ext uri="{FF2B5EF4-FFF2-40B4-BE49-F238E27FC236}">
-                <a16:creationId xmlns:a16="http://schemas.microsoft.com/office/drawing/2014/main" id="{8F8D8D10-2E20-4D48-91A6-D3189DD17C68}"/>
+                <a16:creationId xmlns:a16="http://schemas.microsoft.com/office/drawing/2014/main" id="{D8F5A955-0F33-47DC-928B-1A5BD399D644}"/>
               </a:ext>
             </a:extLst>
           </p:cNvPr>
@@ -2395,7 +2395,7 @@
           <p:cNvPr id="4" name="">
             <a:extLst xmlns:a="http://schemas.openxmlformats.org/drawingml/2006/main">
               <a:ext uri="{FF2B5EF4-FFF2-40B4-BE49-F238E27FC236}">
-                <a16:creationId xmlns:a16="http://schemas.microsoft.com/office/drawing/2014/main" id="{25D36C07-45FA-432C-A049-BF247932C3B5}"/>
+                <a16:creationId xmlns:a16="http://schemas.microsoft.com/office/drawing/2014/main" id="{407A6850-B95A-46BC-BAB2-1C0762173A19}"/>
               </a:ext>
             </a:extLst>
           </p:cNvPr>
@@ -2453,7 +2453,7 @@
           <p:cNvPr id="5" name="">
             <a:extLst xmlns:a="http://schemas.openxmlformats.org/drawingml/2006/main">
               <a:ext uri="{FF2B5EF4-FFF2-40B4-BE49-F238E27FC236}">
-                <a16:creationId xmlns:a16="http://schemas.microsoft.com/office/drawing/2014/main" id="{D1781D41-A98A-4C2C-8A2C-676DA78A473B}"/>
+                <a16:creationId xmlns:a16="http://schemas.microsoft.com/office/drawing/2014/main" id="{FB927F57-EA7B-45E3-AB62-781C14B6EE08}"/>
               </a:ext>
             </a:extLst>
           </p:cNvPr>
@@ -2511,7 +2511,7 @@
           <p:cNvPr id="6" name="">
             <a:extLst xmlns:a="http://schemas.openxmlformats.org/drawingml/2006/main">
               <a:ext uri="{FF2B5EF4-FFF2-40B4-BE49-F238E27FC236}">
-                <a16:creationId xmlns:a16="http://schemas.microsoft.com/office/drawing/2014/main" id="{32E1D6DA-DBF6-4FF0-B977-CFBA812CBDA6}"/>
+                <a16:creationId xmlns:a16="http://schemas.microsoft.com/office/drawing/2014/main" id="{421550E1-D482-4391-9A6F-EE428A1C2F18}"/>
               </a:ext>
             </a:extLst>
           </p:cNvPr>
@@ -2643,7 +2643,7 @@
           <p:cNvPr id="7" name="">
             <a:extLst xmlns:a="http://schemas.openxmlformats.org/drawingml/2006/main">
               <a:ext uri="{FF2B5EF4-FFF2-40B4-BE49-F238E27FC236}">
-                <a16:creationId xmlns:a16="http://schemas.microsoft.com/office/drawing/2014/main" id="{F7F9F981-9884-4BB8-831C-764822FC29BA}"/>
+                <a16:creationId xmlns:a16="http://schemas.microsoft.com/office/drawing/2014/main" id="{28FA49EA-D160-45CA-BF31-F57F56239D40}"/>
               </a:ext>
             </a:extLst>
           </p:cNvPr>
@@ -2701,7 +2701,7 @@
           <p:cNvPr id="8" name="">
             <a:extLst xmlns:a="http://schemas.openxmlformats.org/drawingml/2006/main">
               <a:ext uri="{FF2B5EF4-FFF2-40B4-BE49-F238E27FC236}">
-                <a16:creationId xmlns:a16="http://schemas.microsoft.com/office/drawing/2014/main" id="{B13FE35B-6561-451B-AA03-5420D5411238}"/>
+                <a16:creationId xmlns:a16="http://schemas.microsoft.com/office/drawing/2014/main" id="{420796CA-A9C8-4FC1-9607-C9396AE81295}"/>
               </a:ext>
             </a:extLst>
           </p:cNvPr>
@@ -2833,7 +2833,7 @@
           <p:cNvPr id="9" name="">
             <a:extLst xmlns:a="http://schemas.openxmlformats.org/drawingml/2006/main">
               <a:ext uri="{FF2B5EF4-FFF2-40B4-BE49-F238E27FC236}">
-                <a16:creationId xmlns:a16="http://schemas.microsoft.com/office/drawing/2014/main" id="{5A7F6E0E-FFDF-4941-A0A5-2B154A10DA48}"/>
+                <a16:creationId xmlns:a16="http://schemas.microsoft.com/office/drawing/2014/main" id="{8820955C-4CDD-42C1-A95E-3B09224D2B1E}"/>
               </a:ext>
             </a:extLst>
           </p:cNvPr>
@@ -2889,7 +2889,7 @@
     </p:spTree>
     <p:extLst>
       <p:ext uri="{BB962C8B-B14F-4D97-AF65-F5344CB8AC3E}">
-        <p14:creationId xmlns:p14="http://schemas.microsoft.com/office/powerpoint/2010/main" val="687671488"/>
+        <p14:creationId xmlns:p14="http://schemas.microsoft.com/office/powerpoint/2010/main" val="297897187"/>
       </p:ext>
     </p:extLst>
   </p:cSld>
@@ -2924,13 +2924,13 @@
           <p:nvPr/>
         </p:nvPicPr>
         <p:blipFill>
-          <a:blip xmlns:r="http://schemas.openxmlformats.org/officeDocument/2006/relationships" xmlns:a="http://schemas.openxmlformats.org/drawingml/2006/main" r:embed="Refd78d14ca754df3"/>
+          <a:blip xmlns:r="http://schemas.openxmlformats.org/officeDocument/2006/relationships" xmlns:a="http://schemas.openxmlformats.org/drawingml/2006/main" r:embed="R16be04d383e74f26"/>
           <a:stretch xmlns:a="http://schemas.openxmlformats.org/drawingml/2006/main"/>
         </p:blipFill>
         <p:spPr>
           <a:xfrm xmlns:a="http://schemas.openxmlformats.org/drawingml/2006/main">
-            <a:off x="622041" y="76200"/>
-            <a:ext cx="10947918" cy="6705600"/>
+            <a:off x="449179" y="76200"/>
+            <a:ext cx="11293642" cy="6705600"/>
           </a:xfrm>
           <a:prstGeom xmlns:a="http://schemas.openxmlformats.org/drawingml/2006/main" prst="rect">
             <a:avLst/>
@@ -2940,7 +2940,7 @@
     </p:spTree>
     <p:extLst>
       <p:ext uri="{BB962C8B-B14F-4D97-AF65-F5344CB8AC3E}">
-        <p14:creationId xmlns:p14="http://schemas.microsoft.com/office/powerpoint/2010/main" val="1908932164"/>
+        <p14:creationId xmlns:p14="http://schemas.microsoft.com/office/powerpoint/2010/main" val="1344313309"/>
       </p:ext>
     </p:extLst>
   </p:cSld>
@@ -2971,7 +2971,7 @@
           <p:cNvPr id="15" name="eyebrow-4">
             <a:extLst xmlns:a="http://schemas.openxmlformats.org/drawingml/2006/main">
               <a:ext uri="{FF2B5EF4-FFF2-40B4-BE49-F238E27FC236}">
-                <a16:creationId xmlns:a16="http://schemas.microsoft.com/office/drawing/2014/main" id="{109C49F3-2003-49C3-B301-315ABEC27054}"/>
+                <a16:creationId xmlns:a16="http://schemas.microsoft.com/office/drawing/2014/main" id="{710D3FBF-757E-4E27-BB62-898B9CB2E669}"/>
               </a:ext>
             </a:extLst>
           </p:cNvPr>
@@ -3029,7 +3029,7 @@
           <p:cNvPr id="2" name="title-4">
             <a:extLst xmlns:a="http://schemas.openxmlformats.org/drawingml/2006/main">
               <a:ext uri="{FF2B5EF4-FFF2-40B4-BE49-F238E27FC236}">
-                <a16:creationId xmlns:a16="http://schemas.microsoft.com/office/drawing/2014/main" id="{3B141276-4FDC-4F15-9D86-5A50C042F966}"/>
+                <a16:creationId xmlns:a16="http://schemas.microsoft.com/office/drawing/2014/main" id="{AA5FF86B-AB8E-4AB2-84D9-B58DCD6BF12F}"/>
               </a:ext>
             </a:extLst>
           </p:cNvPr>
@@ -3087,7 +3087,7 @@
           <p:cNvPr id="3" name="">
             <a:extLst xmlns:a="http://schemas.openxmlformats.org/drawingml/2006/main">
               <a:ext uri="{FF2B5EF4-FFF2-40B4-BE49-F238E27FC236}">
-                <a16:creationId xmlns:a16="http://schemas.microsoft.com/office/drawing/2014/main" id="{8BEDA932-E030-445C-BA16-50E1A04FF1CE}"/>
+                <a16:creationId xmlns:a16="http://schemas.microsoft.com/office/drawing/2014/main" id="{00BA3BC2-5101-4308-9995-68A61FA8156A}"/>
               </a:ext>
             </a:extLst>
           </p:cNvPr>
@@ -3118,7 +3118,7 @@
           <p:cNvPr id="4" name="">
             <a:extLst xmlns:a="http://schemas.openxmlformats.org/drawingml/2006/main">
               <a:ext uri="{FF2B5EF4-FFF2-40B4-BE49-F238E27FC236}">
-                <a16:creationId xmlns:a16="http://schemas.microsoft.com/office/drawing/2014/main" id="{3FDD54FE-EE8E-4F58-9A17-4882D794FE7F}"/>
+                <a16:creationId xmlns:a16="http://schemas.microsoft.com/office/drawing/2014/main" id="{D2E7B891-0327-4A64-BB67-481039DCFA40}"/>
               </a:ext>
             </a:extLst>
           </p:cNvPr>
@@ -3176,7 +3176,7 @@
           <p:cNvPr id="5" name="">
             <a:extLst xmlns:a="http://schemas.openxmlformats.org/drawingml/2006/main">
               <a:ext uri="{FF2B5EF4-FFF2-40B4-BE49-F238E27FC236}">
-                <a16:creationId xmlns:a16="http://schemas.microsoft.com/office/drawing/2014/main" id="{7F612172-4338-4129-B985-EA84E9A90EFE}"/>
+                <a16:creationId xmlns:a16="http://schemas.microsoft.com/office/drawing/2014/main" id="{FF46DE00-FA23-4E64-BF6E-9B8E1A9AF1C0}"/>
               </a:ext>
             </a:extLst>
           </p:cNvPr>
@@ -3234,7 +3234,7 @@
           <p:cNvPr id="6" name="">
             <a:extLst xmlns:a="http://schemas.openxmlformats.org/drawingml/2006/main">
               <a:ext uri="{FF2B5EF4-FFF2-40B4-BE49-F238E27FC236}">
-                <a16:creationId xmlns:a16="http://schemas.microsoft.com/office/drawing/2014/main" id="{534DD5D2-266E-46F2-A345-2AE7FFFEEBB3}"/>
+                <a16:creationId xmlns:a16="http://schemas.microsoft.com/office/drawing/2014/main" id="{FF2E36CB-7080-441A-8964-244DF614D9BB}"/>
               </a:ext>
             </a:extLst>
           </p:cNvPr>
@@ -3265,7 +3265,7 @@
           <p:cNvPr id="7" name="">
             <a:extLst xmlns:a="http://schemas.openxmlformats.org/drawingml/2006/main">
               <a:ext uri="{FF2B5EF4-FFF2-40B4-BE49-F238E27FC236}">
-                <a16:creationId xmlns:a16="http://schemas.microsoft.com/office/drawing/2014/main" id="{28F99961-267A-4FB5-AEB3-1E8557EA2D68}"/>
+                <a16:creationId xmlns:a16="http://schemas.microsoft.com/office/drawing/2014/main" id="{A3A8B033-F8C3-4F59-943F-3722DBDA6C69}"/>
               </a:ext>
             </a:extLst>
           </p:cNvPr>
@@ -3351,7 +3351,7 @@
           <p:cNvPr id="8" name="">
             <a:extLst xmlns:a="http://schemas.openxmlformats.org/drawingml/2006/main">
               <a:ext uri="{FF2B5EF4-FFF2-40B4-BE49-F238E27FC236}">
-                <a16:creationId xmlns:a16="http://schemas.microsoft.com/office/drawing/2014/main" id="{BADBC0A2-A7E0-41A8-A147-02BA22D1BB14}"/>
+                <a16:creationId xmlns:a16="http://schemas.microsoft.com/office/drawing/2014/main" id="{1A760703-7374-4BF8-978D-6A7542E895E7}"/>
               </a:ext>
             </a:extLst>
           </p:cNvPr>
@@ -3409,7 +3409,7 @@
           <p:cNvPr id="9" name="">
             <a:extLst xmlns:a="http://schemas.openxmlformats.org/drawingml/2006/main">
               <a:ext uri="{FF2B5EF4-FFF2-40B4-BE49-F238E27FC236}">
-                <a16:creationId xmlns:a16="http://schemas.microsoft.com/office/drawing/2014/main" id="{6A851759-C695-42A3-93C4-281DC3C2956A}"/>
+                <a16:creationId xmlns:a16="http://schemas.microsoft.com/office/drawing/2014/main" id="{42C69C7B-3B55-44C2-9CE9-6EE5F8ACD844}"/>
               </a:ext>
             </a:extLst>
           </p:cNvPr>
@@ -3440,7 +3440,7 @@
           <p:cNvPr id="10" name="">
             <a:extLst xmlns:a="http://schemas.openxmlformats.org/drawingml/2006/main">
               <a:ext uri="{FF2B5EF4-FFF2-40B4-BE49-F238E27FC236}">
-                <a16:creationId xmlns:a16="http://schemas.microsoft.com/office/drawing/2014/main" id="{C24A4FF8-BE3F-498C-A2A3-4054D046A477}"/>
+                <a16:creationId xmlns:a16="http://schemas.microsoft.com/office/drawing/2014/main" id="{7E8EAC11-79A4-4856-86CB-2F3202061C88}"/>
               </a:ext>
             </a:extLst>
           </p:cNvPr>
@@ -3526,7 +3526,7 @@
           <p:cNvPr id="11" name="">
             <a:extLst xmlns:a="http://schemas.openxmlformats.org/drawingml/2006/main">
               <a:ext uri="{FF2B5EF4-FFF2-40B4-BE49-F238E27FC236}">
-                <a16:creationId xmlns:a16="http://schemas.microsoft.com/office/drawing/2014/main" id="{E406D55B-611B-407B-A7C4-F7CC0D054730}"/>
+                <a16:creationId xmlns:a16="http://schemas.microsoft.com/office/drawing/2014/main" id="{5F3206A0-06E1-4E5A-B345-A9DF28500D1E}"/>
               </a:ext>
             </a:extLst>
           </p:cNvPr>
@@ -3584,7 +3584,7 @@
           <p:cNvPr id="12" name="">
             <a:extLst xmlns:a="http://schemas.openxmlformats.org/drawingml/2006/main">
               <a:ext uri="{FF2B5EF4-FFF2-40B4-BE49-F238E27FC236}">
-                <a16:creationId xmlns:a16="http://schemas.microsoft.com/office/drawing/2014/main" id="{FC9E24F5-1855-45F4-89EC-C15896AD238D}"/>
+                <a16:creationId xmlns:a16="http://schemas.microsoft.com/office/drawing/2014/main" id="{A618A580-C125-4583-9ACD-ED2B5EACA23A}"/>
               </a:ext>
             </a:extLst>
           </p:cNvPr>
@@ -3615,7 +3615,7 @@
           <p:cNvPr id="13" name="">
             <a:extLst xmlns:a="http://schemas.openxmlformats.org/drawingml/2006/main">
               <a:ext uri="{FF2B5EF4-FFF2-40B4-BE49-F238E27FC236}">
-                <a16:creationId xmlns:a16="http://schemas.microsoft.com/office/drawing/2014/main" id="{514A17E5-C578-44C5-AE48-EE99BC999C83}"/>
+                <a16:creationId xmlns:a16="http://schemas.microsoft.com/office/drawing/2014/main" id="{200F272A-5B5A-4093-B337-EFD1A73EF19F}"/>
               </a:ext>
             </a:extLst>
           </p:cNvPr>
@@ -3701,7 +3701,7 @@
           <p:cNvPr id="14" name="">
             <a:extLst xmlns:a="http://schemas.openxmlformats.org/drawingml/2006/main">
               <a:ext uri="{FF2B5EF4-FFF2-40B4-BE49-F238E27FC236}">
-                <a16:creationId xmlns:a16="http://schemas.microsoft.com/office/drawing/2014/main" id="{4636CC7F-7B01-481E-BCCD-A47323DEC6DB}"/>
+                <a16:creationId xmlns:a16="http://schemas.microsoft.com/office/drawing/2014/main" id="{452A0EC3-AA02-4A20-8086-B5A31CDF09F4}"/>
               </a:ext>
             </a:extLst>
           </p:cNvPr>
@@ -3757,7 +3757,7 @@
     </p:spTree>
     <p:extLst>
       <p:ext uri="{BB962C8B-B14F-4D97-AF65-F5344CB8AC3E}">
-        <p14:creationId xmlns:p14="http://schemas.microsoft.com/office/powerpoint/2010/main" val="1864827499"/>
+        <p14:creationId xmlns:p14="http://schemas.microsoft.com/office/powerpoint/2010/main" val="1172782855"/>
       </p:ext>
     </p:extLst>
   </p:cSld>
@@ -3788,7 +3788,7 @@
           <p:cNvPr id="22" name="eyebrow-5">
             <a:extLst xmlns:a="http://schemas.openxmlformats.org/drawingml/2006/main">
               <a:ext uri="{FF2B5EF4-FFF2-40B4-BE49-F238E27FC236}">
-                <a16:creationId xmlns:a16="http://schemas.microsoft.com/office/drawing/2014/main" id="{020163F8-7B8D-4E15-8F58-89D541E03A2C}"/>
+                <a16:creationId xmlns:a16="http://schemas.microsoft.com/office/drawing/2014/main" id="{427F1F2F-F6F7-4A29-B2BD-8EA88AAB769C}"/>
               </a:ext>
             </a:extLst>
           </p:cNvPr>
@@ -3846,7 +3846,7 @@
           <p:cNvPr id="2" name="title-5">
             <a:extLst xmlns:a="http://schemas.openxmlformats.org/drawingml/2006/main">
               <a:ext uri="{FF2B5EF4-FFF2-40B4-BE49-F238E27FC236}">
-                <a16:creationId xmlns:a16="http://schemas.microsoft.com/office/drawing/2014/main" id="{B900CD52-83E8-4349-92D7-FC0B07E8DD4C}"/>
+                <a16:creationId xmlns:a16="http://schemas.microsoft.com/office/drawing/2014/main" id="{9D57B243-B242-463B-A88C-4807AACAD336}"/>
               </a:ext>
             </a:extLst>
           </p:cNvPr>
@@ -3904,7 +3904,7 @@
           <p:cNvPr id="3" name="">
             <a:extLst xmlns:a="http://schemas.openxmlformats.org/drawingml/2006/main">
               <a:ext uri="{FF2B5EF4-FFF2-40B4-BE49-F238E27FC236}">
-                <a16:creationId xmlns:a16="http://schemas.microsoft.com/office/drawing/2014/main" id="{2422068E-7D04-4FC5-AFE5-0C339D18499C}"/>
+                <a16:creationId xmlns:a16="http://schemas.microsoft.com/office/drawing/2014/main" id="{D5742A19-0B93-44BD-9B34-0FAD23593CCE}"/>
               </a:ext>
             </a:extLst>
           </p:cNvPr>
@@ -3935,7 +3935,7 @@
           <p:cNvPr id="4" name="">
             <a:extLst xmlns:a="http://schemas.openxmlformats.org/drawingml/2006/main">
               <a:ext uri="{FF2B5EF4-FFF2-40B4-BE49-F238E27FC236}">
-                <a16:creationId xmlns:a16="http://schemas.microsoft.com/office/drawing/2014/main" id="{4884DA35-C2BD-4209-A61F-BB4C4956C523}"/>
+                <a16:creationId xmlns:a16="http://schemas.microsoft.com/office/drawing/2014/main" id="{F202A7A4-4890-4D83-91A8-5BB0D0D3EBD0}"/>
               </a:ext>
             </a:extLst>
           </p:cNvPr>
@@ -3993,7 +3993,7 @@
           <p:cNvPr id="5" name="">
             <a:extLst xmlns:a="http://schemas.openxmlformats.org/drawingml/2006/main">
               <a:ext uri="{FF2B5EF4-FFF2-40B4-BE49-F238E27FC236}">
-                <a16:creationId xmlns:a16="http://schemas.microsoft.com/office/drawing/2014/main" id="{02D02234-4875-477F-9A01-39E90E3FADE9}"/>
+                <a16:creationId xmlns:a16="http://schemas.microsoft.com/office/drawing/2014/main" id="{FC397B50-11B8-44A8-9610-C07CD31F4AFA}"/>
               </a:ext>
             </a:extLst>
           </p:cNvPr>
@@ -4051,7 +4051,7 @@
           <p:cNvPr id="6" name="">
             <a:extLst xmlns:a="http://schemas.openxmlformats.org/drawingml/2006/main">
               <a:ext uri="{FF2B5EF4-FFF2-40B4-BE49-F238E27FC236}">
-                <a16:creationId xmlns:a16="http://schemas.microsoft.com/office/drawing/2014/main" id="{BD314B6A-E541-4ACC-ABEC-2F1777EA1B59}"/>
+                <a16:creationId xmlns:a16="http://schemas.microsoft.com/office/drawing/2014/main" id="{90C3FDB7-014C-4C52-884F-BDB9BBE794F0}"/>
               </a:ext>
             </a:extLst>
           </p:cNvPr>
@@ -4082,7 +4082,7 @@
           <p:cNvPr id="7" name="">
             <a:extLst xmlns:a="http://schemas.openxmlformats.org/drawingml/2006/main">
               <a:ext uri="{FF2B5EF4-FFF2-40B4-BE49-F238E27FC236}">
-                <a16:creationId xmlns:a16="http://schemas.microsoft.com/office/drawing/2014/main" id="{F1D40AB9-D58A-4BE8-AEC0-6C1D86AE649B}"/>
+                <a16:creationId xmlns:a16="http://schemas.microsoft.com/office/drawing/2014/main" id="{08D9DD68-7D5F-41D5-8421-EC3019248552}"/>
               </a:ext>
             </a:extLst>
           </p:cNvPr>
@@ -4113,7 +4113,7 @@
           <p:cNvPr id="8" name="">
             <a:extLst xmlns:a="http://schemas.openxmlformats.org/drawingml/2006/main">
               <a:ext uri="{FF2B5EF4-FFF2-40B4-BE49-F238E27FC236}">
-                <a16:creationId xmlns:a16="http://schemas.microsoft.com/office/drawing/2014/main" id="{C4E5D6C2-B4F1-40CB-967F-05FC133CF6A3}"/>
+                <a16:creationId xmlns:a16="http://schemas.microsoft.com/office/drawing/2014/main" id="{42DA3FC2-3649-40B9-A247-8CFB7F0BAB78}"/>
               </a:ext>
             </a:extLst>
           </p:cNvPr>
@@ -4171,7 +4171,7 @@
           <p:cNvPr id="9" name="">
             <a:extLst xmlns:a="http://schemas.openxmlformats.org/drawingml/2006/main">
               <a:ext uri="{FF2B5EF4-FFF2-40B4-BE49-F238E27FC236}">
-                <a16:creationId xmlns:a16="http://schemas.microsoft.com/office/drawing/2014/main" id="{C7B04F81-C0CA-4CB5-B4E5-BCD482CCAD0B}"/>
+                <a16:creationId xmlns:a16="http://schemas.microsoft.com/office/drawing/2014/main" id="{112370FB-0714-40BB-A9FA-58FC4A2EB136}"/>
               </a:ext>
             </a:extLst>
           </p:cNvPr>
@@ -4229,7 +4229,7 @@
           <p:cNvPr id="10" name="">
             <a:extLst xmlns:a="http://schemas.openxmlformats.org/drawingml/2006/main">
               <a:ext uri="{FF2B5EF4-FFF2-40B4-BE49-F238E27FC236}">
-                <a16:creationId xmlns:a16="http://schemas.microsoft.com/office/drawing/2014/main" id="{827797D8-9EF7-4B81-A3FC-56ED0E5F0CFF}"/>
+                <a16:creationId xmlns:a16="http://schemas.microsoft.com/office/drawing/2014/main" id="{DE46ACBC-9414-4D0A-857A-C0C24099028C}"/>
               </a:ext>
             </a:extLst>
           </p:cNvPr>
@@ -4287,7 +4287,7 @@
           <p:cNvPr id="11" name="">
             <a:extLst xmlns:a="http://schemas.openxmlformats.org/drawingml/2006/main">
               <a:ext uri="{FF2B5EF4-FFF2-40B4-BE49-F238E27FC236}">
-                <a16:creationId xmlns:a16="http://schemas.microsoft.com/office/drawing/2014/main" id="{7B1C1F74-6A58-44D3-8423-0B38C815632E}"/>
+                <a16:creationId xmlns:a16="http://schemas.microsoft.com/office/drawing/2014/main" id="{F422721F-F8A8-42FC-AFAC-DB70E46D6EC2}"/>
               </a:ext>
             </a:extLst>
           </p:cNvPr>
@@ -4318,7 +4318,7 @@
           <p:cNvPr id="12" name="">
             <a:extLst xmlns:a="http://schemas.openxmlformats.org/drawingml/2006/main">
               <a:ext uri="{FF2B5EF4-FFF2-40B4-BE49-F238E27FC236}">
-                <a16:creationId xmlns:a16="http://schemas.microsoft.com/office/drawing/2014/main" id="{B8FA21F4-4326-44ED-9062-2BD9AC2E535D}"/>
+                <a16:creationId xmlns:a16="http://schemas.microsoft.com/office/drawing/2014/main" id="{9EDD3262-6DA1-401B-8FD1-2104DFF4F84A}"/>
               </a:ext>
             </a:extLst>
           </p:cNvPr>
@@ -4349,7 +4349,7 @@
           <p:cNvPr id="13" name="">
             <a:extLst xmlns:a="http://schemas.openxmlformats.org/drawingml/2006/main">
               <a:ext uri="{FF2B5EF4-FFF2-40B4-BE49-F238E27FC236}">
-                <a16:creationId xmlns:a16="http://schemas.microsoft.com/office/drawing/2014/main" id="{ECAAC392-5EDA-424E-BEC2-69831D15D3A0}"/>
+                <a16:creationId xmlns:a16="http://schemas.microsoft.com/office/drawing/2014/main" id="{C2D04833-C4EE-4BA9-864C-6342F5E62603}"/>
               </a:ext>
             </a:extLst>
           </p:cNvPr>
@@ -4407,7 +4407,7 @@
           <p:cNvPr id="14" name="">
             <a:extLst xmlns:a="http://schemas.openxmlformats.org/drawingml/2006/main">
               <a:ext uri="{FF2B5EF4-FFF2-40B4-BE49-F238E27FC236}">
-                <a16:creationId xmlns:a16="http://schemas.microsoft.com/office/drawing/2014/main" id="{744E7AA7-D1A1-4BF5-886F-852E36873F0D}"/>
+                <a16:creationId xmlns:a16="http://schemas.microsoft.com/office/drawing/2014/main" id="{02EC2970-742A-4BF7-A1F9-C667B4F7F3A4}"/>
               </a:ext>
             </a:extLst>
           </p:cNvPr>
@@ -4465,7 +4465,7 @@
           <p:cNvPr id="15" name="">
             <a:extLst xmlns:a="http://schemas.openxmlformats.org/drawingml/2006/main">
               <a:ext uri="{FF2B5EF4-FFF2-40B4-BE49-F238E27FC236}">
-                <a16:creationId xmlns:a16="http://schemas.microsoft.com/office/drawing/2014/main" id="{5B86AF56-48FF-4AC8-9DDB-69E022E332A1}"/>
+                <a16:creationId xmlns:a16="http://schemas.microsoft.com/office/drawing/2014/main" id="{81B35879-C6F8-421E-AD94-86E7E92A3253}"/>
               </a:ext>
             </a:extLst>
           </p:cNvPr>
@@ -4523,7 +4523,7 @@
           <p:cNvPr id="16" name="">
             <a:extLst xmlns:a="http://schemas.openxmlformats.org/drawingml/2006/main">
               <a:ext uri="{FF2B5EF4-FFF2-40B4-BE49-F238E27FC236}">
-                <a16:creationId xmlns:a16="http://schemas.microsoft.com/office/drawing/2014/main" id="{25039CB2-C15A-4EE3-99F0-8D3179B7CB38}"/>
+                <a16:creationId xmlns:a16="http://schemas.microsoft.com/office/drawing/2014/main" id="{F2CD09B0-3090-401D-AEBE-95DDD3B35BB7}"/>
               </a:ext>
             </a:extLst>
           </p:cNvPr>
@@ -4554,7 +4554,7 @@
           <p:cNvPr id="17" name="">
             <a:extLst xmlns:a="http://schemas.openxmlformats.org/drawingml/2006/main">
               <a:ext uri="{FF2B5EF4-FFF2-40B4-BE49-F238E27FC236}">
-                <a16:creationId xmlns:a16="http://schemas.microsoft.com/office/drawing/2014/main" id="{7ED41CDA-2E16-4B3A-8192-B3312FED2CD5}"/>
+                <a16:creationId xmlns:a16="http://schemas.microsoft.com/office/drawing/2014/main" id="{C2A389C2-445B-47AC-8895-2FAC52E32F0A}"/>
               </a:ext>
             </a:extLst>
           </p:cNvPr>
@@ -4585,7 +4585,7 @@
           <p:cNvPr id="18" name="">
             <a:extLst xmlns:a="http://schemas.openxmlformats.org/drawingml/2006/main">
               <a:ext uri="{FF2B5EF4-FFF2-40B4-BE49-F238E27FC236}">
-                <a16:creationId xmlns:a16="http://schemas.microsoft.com/office/drawing/2014/main" id="{67416168-8BB2-417C-AAA6-57198A3EEE63}"/>
+                <a16:creationId xmlns:a16="http://schemas.microsoft.com/office/drawing/2014/main" id="{AF12AF38-394B-487C-9CC7-ACEFECFF91B2}"/>
               </a:ext>
             </a:extLst>
           </p:cNvPr>
@@ -4643,7 +4643,7 @@
           <p:cNvPr id="19" name="">
             <a:extLst xmlns:a="http://schemas.openxmlformats.org/drawingml/2006/main">
               <a:ext uri="{FF2B5EF4-FFF2-40B4-BE49-F238E27FC236}">
-                <a16:creationId xmlns:a16="http://schemas.microsoft.com/office/drawing/2014/main" id="{DDE71FE9-D8A4-418C-93DA-719056FD4A49}"/>
+                <a16:creationId xmlns:a16="http://schemas.microsoft.com/office/drawing/2014/main" id="{6F1228C5-28F2-4C08-91B9-DE88BEA759C0}"/>
               </a:ext>
             </a:extLst>
           </p:cNvPr>
@@ -4701,7 +4701,7 @@
           <p:cNvPr id="20" name="">
             <a:extLst xmlns:a="http://schemas.openxmlformats.org/drawingml/2006/main">
               <a:ext uri="{FF2B5EF4-FFF2-40B4-BE49-F238E27FC236}">
-                <a16:creationId xmlns:a16="http://schemas.microsoft.com/office/drawing/2014/main" id="{750C971E-8931-4194-B4F1-687FBA10538D}"/>
+                <a16:creationId xmlns:a16="http://schemas.microsoft.com/office/drawing/2014/main" id="{8073699F-BF06-4BEE-9B77-38056579C38A}"/>
               </a:ext>
             </a:extLst>
           </p:cNvPr>
@@ -4759,7 +4759,7 @@
           <p:cNvPr id="21" name="">
             <a:extLst xmlns:a="http://schemas.openxmlformats.org/drawingml/2006/main">
               <a:ext uri="{FF2B5EF4-FFF2-40B4-BE49-F238E27FC236}">
-                <a16:creationId xmlns:a16="http://schemas.microsoft.com/office/drawing/2014/main" id="{27949446-43B9-4F94-BD5E-5421419CB8C7}"/>
+                <a16:creationId xmlns:a16="http://schemas.microsoft.com/office/drawing/2014/main" id="{18CCACFF-D7A5-4F7A-8963-FBA21E1787E5}"/>
               </a:ext>
             </a:extLst>
           </p:cNvPr>
@@ -4815,7 +4815,7 @@
     </p:spTree>
     <p:extLst>
       <p:ext uri="{BB962C8B-B14F-4D97-AF65-F5344CB8AC3E}">
-        <p14:creationId xmlns:p14="http://schemas.microsoft.com/office/powerpoint/2010/main" val="1514054281"/>
+        <p14:creationId xmlns:p14="http://schemas.microsoft.com/office/powerpoint/2010/main" val="881096770"/>
       </p:ext>
     </p:extLst>
   </p:cSld>
@@ -4846,7 +4846,7 @@
           <p:cNvPr id="10" name="eyebrow-6">
             <a:extLst xmlns:a="http://schemas.openxmlformats.org/drawingml/2006/main">
               <a:ext uri="{FF2B5EF4-FFF2-40B4-BE49-F238E27FC236}">
-                <a16:creationId xmlns:a16="http://schemas.microsoft.com/office/drawing/2014/main" id="{91F56B7A-B2D9-4EBB-B4FB-803B54F46A12}"/>
+                <a16:creationId xmlns:a16="http://schemas.microsoft.com/office/drawing/2014/main" id="{B1FD83D7-C733-4CA3-957C-34B308A92463}"/>
               </a:ext>
             </a:extLst>
           </p:cNvPr>
@@ -4904,7 +4904,7 @@
           <p:cNvPr id="2" name="title-6">
             <a:extLst xmlns:a="http://schemas.openxmlformats.org/drawingml/2006/main">
               <a:ext uri="{FF2B5EF4-FFF2-40B4-BE49-F238E27FC236}">
-                <a16:creationId xmlns:a16="http://schemas.microsoft.com/office/drawing/2014/main" id="{E2EF3ECF-AB55-49F4-9F7C-1FC1CE5816D4}"/>
+                <a16:creationId xmlns:a16="http://schemas.microsoft.com/office/drawing/2014/main" id="{DC905819-4009-4CA3-B5B2-8F148F8C1FB1}"/>
               </a:ext>
             </a:extLst>
           </p:cNvPr>
@@ -4962,7 +4962,7 @@
           <p:cNvPr id="3" name="">
             <a:extLst xmlns:a="http://schemas.openxmlformats.org/drawingml/2006/main">
               <a:ext uri="{FF2B5EF4-FFF2-40B4-BE49-F238E27FC236}">
-                <a16:creationId xmlns:a16="http://schemas.microsoft.com/office/drawing/2014/main" id="{C917260D-4150-4773-991D-6D7582325622}"/>
+                <a16:creationId xmlns:a16="http://schemas.microsoft.com/office/drawing/2014/main" id="{98F3267E-61C0-43FD-8440-971A5956AF06}"/>
               </a:ext>
             </a:extLst>
           </p:cNvPr>
@@ -4993,7 +4993,7 @@
           <p:cNvPr id="4" name="">
             <a:extLst xmlns:a="http://schemas.openxmlformats.org/drawingml/2006/main">
               <a:ext uri="{FF2B5EF4-FFF2-40B4-BE49-F238E27FC236}">
-                <a16:creationId xmlns:a16="http://schemas.microsoft.com/office/drawing/2014/main" id="{F48BEB7A-4E22-4FEC-9718-B98508FC8CA0}"/>
+                <a16:creationId xmlns:a16="http://schemas.microsoft.com/office/drawing/2014/main" id="{E90D0B52-8B04-4ADD-823A-A6060B6C8E30}"/>
               </a:ext>
             </a:extLst>
           </p:cNvPr>
@@ -5055,7 +5055,7 @@
           <p:nvPr/>
         </p:nvPicPr>
         <p:blipFill>
-          <a:blip xmlns:r="http://schemas.openxmlformats.org/officeDocument/2006/relationships" xmlns:a="http://schemas.openxmlformats.org/drawingml/2006/main" r:embed="Raa0a04f5fb404d68"/>
+          <a:blip xmlns:r="http://schemas.openxmlformats.org/officeDocument/2006/relationships" xmlns:a="http://schemas.openxmlformats.org/drawingml/2006/main" r:embed="Ra37be132f364426e"/>
           <a:stretch xmlns:a="http://schemas.openxmlformats.org/drawingml/2006/main"/>
         </p:blipFill>
         <p:spPr>
@@ -5077,7 +5077,7 @@
           <p:nvPr/>
         </p:nvPicPr>
         <p:blipFill>
-          <a:blip xmlns:r="http://schemas.openxmlformats.org/officeDocument/2006/relationships" xmlns:a="http://schemas.openxmlformats.org/drawingml/2006/main" r:embed="Rd52f8d21bbc74e54"/>
+          <a:blip xmlns:r="http://schemas.openxmlformats.org/officeDocument/2006/relationships" xmlns:a="http://schemas.openxmlformats.org/drawingml/2006/main" r:embed="R848e8671080e4811"/>
           <a:stretch xmlns:a="http://schemas.openxmlformats.org/drawingml/2006/main"/>
         </p:blipFill>
         <p:spPr>
@@ -5095,7 +5095,7 @@
           <p:cNvPr id="7" name="">
             <a:extLst xmlns:a="http://schemas.openxmlformats.org/drawingml/2006/main">
               <a:ext uri="{FF2B5EF4-FFF2-40B4-BE49-F238E27FC236}">
-                <a16:creationId xmlns:a16="http://schemas.microsoft.com/office/drawing/2014/main" id="{4250AB54-1A54-4130-9DC6-7948FA6484E6}"/>
+                <a16:creationId xmlns:a16="http://schemas.microsoft.com/office/drawing/2014/main" id="{F1F8CE96-1C76-4229-B5A2-D85C8DD219BC}"/>
               </a:ext>
             </a:extLst>
           </p:cNvPr>
@@ -5153,7 +5153,7 @@
           <p:cNvPr id="8" name="">
             <a:extLst xmlns:a="http://schemas.openxmlformats.org/drawingml/2006/main">
               <a:ext uri="{FF2B5EF4-FFF2-40B4-BE49-F238E27FC236}">
-                <a16:creationId xmlns:a16="http://schemas.microsoft.com/office/drawing/2014/main" id="{D112CD2B-53E0-4DAA-9220-36D924CC632F}"/>
+                <a16:creationId xmlns:a16="http://schemas.microsoft.com/office/drawing/2014/main" id="{7C3903C8-72CB-409A-96CB-615141A24555}"/>
               </a:ext>
             </a:extLst>
           </p:cNvPr>
@@ -5211,7 +5211,7 @@
           <p:cNvPr id="9" name="">
             <a:extLst xmlns:a="http://schemas.openxmlformats.org/drawingml/2006/main">
               <a:ext uri="{FF2B5EF4-FFF2-40B4-BE49-F238E27FC236}">
-                <a16:creationId xmlns:a16="http://schemas.microsoft.com/office/drawing/2014/main" id="{67EDEEE9-C7F1-45C6-A410-690D3DE9FDF6}"/>
+                <a16:creationId xmlns:a16="http://schemas.microsoft.com/office/drawing/2014/main" id="{BE8074D6-A29A-4C09-8B93-1AFDC6925987}"/>
               </a:ext>
             </a:extLst>
           </p:cNvPr>
@@ -5267,7 +5267,7 @@
     </p:spTree>
     <p:extLst>
       <p:ext uri="{BB962C8B-B14F-4D97-AF65-F5344CB8AC3E}">
-        <p14:creationId xmlns:p14="http://schemas.microsoft.com/office/powerpoint/2010/main" val="152508536"/>
+        <p14:creationId xmlns:p14="http://schemas.microsoft.com/office/powerpoint/2010/main" val="387822540"/>
       </p:ext>
     </p:extLst>
   </p:cSld>
@@ -5298,7 +5298,7 @@
           <p:cNvPr id="10" name="">
             <a:extLst xmlns:a="http://schemas.openxmlformats.org/drawingml/2006/main">
               <a:ext uri="{FF2B5EF4-FFF2-40B4-BE49-F238E27FC236}">
-                <a16:creationId xmlns:a16="http://schemas.microsoft.com/office/drawing/2014/main" id="{0CF8B2E2-00F5-468F-B7A7-DB122014F6AE}"/>
+                <a16:creationId xmlns:a16="http://schemas.microsoft.com/office/drawing/2014/main" id="{51D9B6ED-8397-4481-80E5-43DE7981596E}"/>
               </a:ext>
             </a:extLst>
           </p:cNvPr>
@@ -5356,7 +5356,7 @@
           <p:cNvPr id="2" name="">
             <a:extLst xmlns:a="http://schemas.openxmlformats.org/drawingml/2006/main">
               <a:ext uri="{FF2B5EF4-FFF2-40B4-BE49-F238E27FC236}">
-                <a16:creationId xmlns:a16="http://schemas.microsoft.com/office/drawing/2014/main" id="{AAE0E8CD-024E-41BE-B6F0-0796F948CABD}"/>
+                <a16:creationId xmlns:a16="http://schemas.microsoft.com/office/drawing/2014/main" id="{44AF6880-34D0-4C9F-B03E-CFBBFEE8B85D}"/>
               </a:ext>
             </a:extLst>
           </p:cNvPr>
@@ -5437,7 +5437,7 @@
           <p:cNvPr id="3" name="">
             <a:extLst xmlns:a="http://schemas.openxmlformats.org/drawingml/2006/main">
               <a:ext uri="{FF2B5EF4-FFF2-40B4-BE49-F238E27FC236}">
-                <a16:creationId xmlns:a16="http://schemas.microsoft.com/office/drawing/2014/main" id="{AAD71DF9-BC6E-4FFE-AC8A-356215604D6B}"/>
+                <a16:creationId xmlns:a16="http://schemas.microsoft.com/office/drawing/2014/main" id="{5CCD5217-A467-4DC2-BB82-4605767B3148}"/>
               </a:ext>
             </a:extLst>
           </p:cNvPr>
@@ -5495,7 +5495,7 @@
           <p:cNvPr id="4" name="">
             <a:extLst xmlns:a="http://schemas.openxmlformats.org/drawingml/2006/main">
               <a:ext uri="{FF2B5EF4-FFF2-40B4-BE49-F238E27FC236}">
-                <a16:creationId xmlns:a16="http://schemas.microsoft.com/office/drawing/2014/main" id="{7BE6D8A0-E611-4C15-B5EE-3A8458598977}"/>
+                <a16:creationId xmlns:a16="http://schemas.microsoft.com/office/drawing/2014/main" id="{7F07B143-46F6-46C3-ACED-C6140E583E83}"/>
               </a:ext>
             </a:extLst>
           </p:cNvPr>
@@ -5576,7 +5576,7 @@
           <p:cNvPr id="5" name="">
             <a:extLst xmlns:a="http://schemas.openxmlformats.org/drawingml/2006/main">
               <a:ext uri="{FF2B5EF4-FFF2-40B4-BE49-F238E27FC236}">
-                <a16:creationId xmlns:a16="http://schemas.microsoft.com/office/drawing/2014/main" id="{69D22CDA-0FBA-4DA8-9EAB-46D9012EF6E5}"/>
+                <a16:creationId xmlns:a16="http://schemas.microsoft.com/office/drawing/2014/main" id="{501CA750-0036-46C9-AFBC-D7B56D1821C7}"/>
               </a:ext>
             </a:extLst>
           </p:cNvPr>
@@ -5634,7 +5634,7 @@
           <p:cNvPr id="6" name="">
             <a:extLst xmlns:a="http://schemas.openxmlformats.org/drawingml/2006/main">
               <a:ext uri="{FF2B5EF4-FFF2-40B4-BE49-F238E27FC236}">
-                <a16:creationId xmlns:a16="http://schemas.microsoft.com/office/drawing/2014/main" id="{84AAA231-D95F-47E8-A62F-9C4A1BD46605}"/>
+                <a16:creationId xmlns:a16="http://schemas.microsoft.com/office/drawing/2014/main" id="{5002CAE1-7CFC-4B7B-AA01-7FC881E315C4}"/>
               </a:ext>
             </a:extLst>
           </p:cNvPr>
@@ -5715,7 +5715,7 @@
           <p:cNvPr id="7" name="">
             <a:extLst xmlns:a="http://schemas.openxmlformats.org/drawingml/2006/main">
               <a:ext uri="{FF2B5EF4-FFF2-40B4-BE49-F238E27FC236}">
-                <a16:creationId xmlns:a16="http://schemas.microsoft.com/office/drawing/2014/main" id="{103D01C4-ADEF-45C1-B7A2-FAAE8C19B31A}"/>
+                <a16:creationId xmlns:a16="http://schemas.microsoft.com/office/drawing/2014/main" id="{C7D00805-A990-4CE1-89CB-BFA2537BB9C5}"/>
               </a:ext>
             </a:extLst>
           </p:cNvPr>
@@ -5746,7 +5746,7 @@
           <p:cNvPr id="8" name="">
             <a:extLst xmlns:a="http://schemas.openxmlformats.org/drawingml/2006/main">
               <a:ext uri="{FF2B5EF4-FFF2-40B4-BE49-F238E27FC236}">
-                <a16:creationId xmlns:a16="http://schemas.microsoft.com/office/drawing/2014/main" id="{BADBF074-8F11-4A23-8F18-057C3085A52E}"/>
+                <a16:creationId xmlns:a16="http://schemas.microsoft.com/office/drawing/2014/main" id="{40DA8A41-B074-4AAC-BACA-66CAD96B8858}"/>
               </a:ext>
             </a:extLst>
           </p:cNvPr>
@@ -5804,7 +5804,7 @@
           <p:cNvPr id="9" name="">
             <a:extLst xmlns:a="http://schemas.openxmlformats.org/drawingml/2006/main">
               <a:ext uri="{FF2B5EF4-FFF2-40B4-BE49-F238E27FC236}">
-                <a16:creationId xmlns:a16="http://schemas.microsoft.com/office/drawing/2014/main" id="{C3A4A65A-6AE8-4961-AD67-0CE9628081FF}"/>
+                <a16:creationId xmlns:a16="http://schemas.microsoft.com/office/drawing/2014/main" id="{C6EAD8C2-26E1-4608-891A-E944B635EAAC}"/>
               </a:ext>
             </a:extLst>
           </p:cNvPr>
@@ -5860,7 +5860,7 @@
     </p:spTree>
     <p:extLst>
       <p:ext uri="{BB962C8B-B14F-4D97-AF65-F5344CB8AC3E}">
-        <p14:creationId xmlns:p14="http://schemas.microsoft.com/office/powerpoint/2010/main" val="1689975406"/>
+        <p14:creationId xmlns:p14="http://schemas.microsoft.com/office/powerpoint/2010/main" val="2025065397"/>
       </p:ext>
     </p:extLst>
   </p:cSld>

</xml_diff>

<commit_message>
docs: make actual ingestion evidence reproducible
</commit_message>
<xml_diff>
--- a/docs/presentation/us-market-pipeline-assignment.pptx
+++ b/docs/presentation/us-market-pipeline-assignment.pptx
@@ -2,19 +2,19 @@
 <file path=ppt/presentation.xml><?xml version="1.0" encoding="utf-8"?>
 <p:presentation xmlns:p="http://schemas.openxmlformats.org/presentationml/2006/main">
   <p:sldMasterIdLst>
-    <p:sldMasterId xmlns:r="http://schemas.openxmlformats.org/officeDocument/2006/relationships" id="2147483648" r:id="Re4981895e29f406e"/>
+    <p:sldMasterId xmlns:r="http://schemas.openxmlformats.org/officeDocument/2006/relationships" id="2147483648" r:id="R3c74cbf8fd404a93"/>
   </p:sldMasterIdLst>
   <p:notesMasterIdLst>
-    <p:notesMasterId xmlns:r="http://schemas.openxmlformats.org/officeDocument/2006/relationships" r:id="R7bbe9e3e7b624cb7"/>
+    <p:notesMasterId xmlns:r="http://schemas.openxmlformats.org/officeDocument/2006/relationships" r:id="R9df53b7480dd4a7d"/>
   </p:notesMasterIdLst>
   <p:sldIdLst>
-    <p:sldId xmlns:r="http://schemas.openxmlformats.org/officeDocument/2006/relationships" id="256" r:id="R73dcc721ee4240ec"/>
-    <p:sldId xmlns:r="http://schemas.openxmlformats.org/officeDocument/2006/relationships" id="257" r:id="R453386b0dfb14635"/>
-    <p:sldId xmlns:r="http://schemas.openxmlformats.org/officeDocument/2006/relationships" id="258" r:id="R2934d8a7ae834767"/>
-    <p:sldId xmlns:r="http://schemas.openxmlformats.org/officeDocument/2006/relationships" id="259" r:id="R705ef5b1b98f4c12"/>
-    <p:sldId xmlns:r="http://schemas.openxmlformats.org/officeDocument/2006/relationships" id="260" r:id="Rbc7edaa061254213"/>
-    <p:sldId xmlns:r="http://schemas.openxmlformats.org/officeDocument/2006/relationships" id="261" r:id="Rcfdf33eb27974383"/>
-    <p:sldId xmlns:r="http://schemas.openxmlformats.org/officeDocument/2006/relationships" id="262" r:id="Rf878ad8d5e604a5a"/>
+    <p:sldId xmlns:r="http://schemas.openxmlformats.org/officeDocument/2006/relationships" id="256" r:id="Rf1de833356e14f92"/>
+    <p:sldId xmlns:r="http://schemas.openxmlformats.org/officeDocument/2006/relationships" id="257" r:id="R7b4c4d1584c64295"/>
+    <p:sldId xmlns:r="http://schemas.openxmlformats.org/officeDocument/2006/relationships" id="258" r:id="R1b59cbfa43db4b6f"/>
+    <p:sldId xmlns:r="http://schemas.openxmlformats.org/officeDocument/2006/relationships" id="259" r:id="Rc436f709230f471c"/>
+    <p:sldId xmlns:r="http://schemas.openxmlformats.org/officeDocument/2006/relationships" id="260" r:id="Rc1d26bd2fd3d4a8f"/>
+    <p:sldId xmlns:r="http://schemas.openxmlformats.org/officeDocument/2006/relationships" id="261" r:id="R67335da551194e20"/>
+    <p:sldId xmlns:r="http://schemas.openxmlformats.org/officeDocument/2006/relationships" id="262" r:id="R1eef359c5a3b4bfa"/>
   </p:sldIdLst>
   <p:sldSz cx="12192000" cy="6858000"/>
   <p:notesSz cx="6858000" cy="9144000"/>
@@ -838,7 +838,7 @@
           <a:lstStyle xmlns:a="http://schemas.openxmlformats.org/drawingml/2006/main"/>
           <a:p xmlns:a="http://schemas.openxmlformats.org/drawingml/2006/main">
             <a:r>
-              <a:t>실제 결과입니다. SMH 거래 427건을 API에서 가져왔고 427건 모두 Kafka에 발행했습니다. Spark는 2분 watermark를 적용해서 확정 가능한 구간만 계산했고, PostgreSQL에는 1분봉 3건이 저장됐습니다. business key 중복은 0건입니다. 마지막 구간이 적게 저장된 이유는 데이터가 사라진 것이 아니라 늦게 오는 거래를 기다리는 설계이기 때문입니다.</a:t>
+              <a:t>실제 결과입니다. SMH 거래 427건을 API에서 가져와 Kafka에 모두 발행했습니다. 이 실행 종료 시점에는 그중 174건이 watermark를 통과한 확정 1분봉 3건에 반영됐고, business key 중복은 0건입니다. 나머지 구간은 아직 final row로 저장되지 않았으며 checkpoint를 유지하고 event-time이 진행되면 확정될 수 있습니다.</a:t>
             </a:r>
           </a:p>
           <a:p xmlns:a="http://schemas.openxmlformats.org/drawingml/2006/main">
@@ -1126,7 +1126,7 @@
   </p:cSld>
   <p:clrMap bg1="lt1" tx1="dk1" bg2="lt2" tx2="dk2" accent1="accent1" accent2="accent2" accent3="accent3" accent4="accent4" accent5="accent5" accent6="accent6" hlink="hlink" folHlink="folHlink"/>
   <p:sldLayoutIdLst>
-    <p:sldLayoutId xmlns:r="http://schemas.openxmlformats.org/officeDocument/2006/relationships" id="2147483649" r:id="Rc718fb8ff0c44ea5"/>
+    <p:sldLayoutId xmlns:r="http://schemas.openxmlformats.org/officeDocument/2006/relationships" id="2147483649" r:id="R096cee767e0d4281"/>
   </p:sldLayoutIdLst>
   <p:txStyles>
     <p:titleStyle>
@@ -1707,6 +1707,7 @@
           <a:lstStyle xmlns:a="http://schemas.openxmlformats.org/drawingml/2006/main"/>
           <a:p xmlns:a="http://schemas.openxmlformats.org/drawingml/2006/main">
             <a:pPr algn="l">
+              <a:buNone/>
               <a:defRPr sz="1200" b="1">
                 <a:solidFill>
                   <a:srgbClr val="1570EF"/>
@@ -1765,6 +1766,7 @@
           <a:lstStyle xmlns:a="http://schemas.openxmlformats.org/drawingml/2006/main"/>
           <a:p xmlns:a="http://schemas.openxmlformats.org/drawingml/2006/main">
             <a:pPr algn="l">
+              <a:buNone/>
               <a:defRPr sz="3825" b="1">
                 <a:solidFill>
                   <a:srgbClr val="101828"/>
@@ -1788,6 +1790,7 @@
           </a:p>
           <a:p xmlns:a="http://schemas.openxmlformats.org/drawingml/2006/main">
             <a:pPr algn="l">
+              <a:buNone/>
               <a:defRPr sz="3825" b="1">
                 <a:solidFill>
                   <a:srgbClr val="101828"/>
@@ -1846,6 +1849,7 @@
           <a:lstStyle xmlns:a="http://schemas.openxmlformats.org/drawingml/2006/main"/>
           <a:p xmlns:a="http://schemas.openxmlformats.org/drawingml/2006/main">
             <a:pPr algn="l">
+              <a:buNone/>
               <a:defRPr sz="1725" b="1">
                 <a:solidFill>
                   <a:srgbClr val="101828"/>
@@ -1904,6 +1908,7 @@
           <a:lstStyle xmlns:a="http://schemas.openxmlformats.org/drawingml/2006/main"/>
           <a:p xmlns:a="http://schemas.openxmlformats.org/drawingml/2006/main">
             <a:pPr algn="l">
+              <a:buNone/>
               <a:defRPr sz="1575" b="0">
                 <a:solidFill>
                   <a:srgbClr val="667085"/>
@@ -1962,6 +1967,7 @@
           <a:lstStyle xmlns:a="http://schemas.openxmlformats.org/drawingml/2006/main"/>
           <a:p xmlns:a="http://schemas.openxmlformats.org/drawingml/2006/main">
             <a:pPr algn="l">
+              <a:buNone/>
               <a:defRPr sz="1350" b="1">
                 <a:solidFill>
                   <a:srgbClr val="1570EF"/>
@@ -2020,14 +2026,14 @@
       </p:sp>
       <p:pic>
         <p:nvPicPr>
-          <p:cNvPr id="17" name=""/>
+          <p:cNvPr id="19" name=""/>
           <p:cNvPicPr>
             <a:picLocks xmlns:a="http://schemas.openxmlformats.org/drawingml/2006/main" noChangeAspect="1"/>
           </p:cNvPicPr>
           <p:nvPr/>
         </p:nvPicPr>
         <p:blipFill>
-          <a:blip xmlns:r="http://schemas.openxmlformats.org/officeDocument/2006/relationships" xmlns:a="http://schemas.openxmlformats.org/drawingml/2006/main" r:embed="R7dc7f43128454b98"/>
+          <a:blip xmlns:r="http://schemas.openxmlformats.org/officeDocument/2006/relationships" xmlns:a="http://schemas.openxmlformats.org/drawingml/2006/main" r:embed="Reb4adf7d90a04c5f"/>
           <a:stretch xmlns:a="http://schemas.openxmlformats.org/drawingml/2006/main"/>
         </p:blipFill>
         <p:spPr>
@@ -2075,6 +2081,7 @@
           <a:lstStyle xmlns:a="http://schemas.openxmlformats.org/drawingml/2006/main"/>
           <a:p xmlns:a="http://schemas.openxmlformats.org/drawingml/2006/main">
             <a:pPr algn="l">
+              <a:buNone/>
               <a:defRPr sz="1725" b="1">
                 <a:solidFill>
                   <a:srgbClr val="1570EF"/>
@@ -2133,6 +2140,7 @@
           <a:lstStyle xmlns:a="http://schemas.openxmlformats.org/drawingml/2006/main"/>
           <a:p xmlns:a="http://schemas.openxmlformats.org/drawingml/2006/main">
             <a:pPr algn="l">
+              <a:buNone/>
               <a:defRPr sz="1425" b="0">
                 <a:solidFill>
                   <a:srgbClr val="101828"/>
@@ -2191,6 +2199,7 @@
           <a:lstStyle xmlns:a="http://schemas.openxmlformats.org/drawingml/2006/main"/>
           <a:p xmlns:a="http://schemas.openxmlformats.org/drawingml/2006/main">
             <a:pPr algn="r">
+              <a:buNone/>
               <a:defRPr sz="900" b="0">
                 <a:solidFill>
                   <a:srgbClr val="667085"/>
@@ -2278,6 +2287,7 @@
           <a:lstStyle xmlns:a="http://schemas.openxmlformats.org/drawingml/2006/main"/>
           <a:p xmlns:a="http://schemas.openxmlformats.org/drawingml/2006/main">
             <a:pPr algn="l">
+              <a:buNone/>
               <a:defRPr sz="1125" b="1">
                 <a:solidFill>
                   <a:srgbClr val="1570EF"/>
@@ -2336,6 +2346,7 @@
           <a:lstStyle xmlns:a="http://schemas.openxmlformats.org/drawingml/2006/main"/>
           <a:p xmlns:a="http://schemas.openxmlformats.org/drawingml/2006/main">
             <a:pPr algn="l">
+              <a:buNone/>
               <a:defRPr sz="2850" b="1">
                 <a:solidFill>
                   <a:srgbClr val="101828"/>
@@ -2425,6 +2436,7 @@
           <a:lstStyle xmlns:a="http://schemas.openxmlformats.org/drawingml/2006/main"/>
           <a:p xmlns:a="http://schemas.openxmlformats.org/drawingml/2006/main">
             <a:pPr algn="r">
+              <a:buNone/>
               <a:defRPr sz="900" b="0">
                 <a:solidFill>
                   <a:srgbClr val="667085"/>
@@ -2483,6 +2495,7 @@
           <a:lstStyle xmlns:a="http://schemas.openxmlformats.org/drawingml/2006/main"/>
           <a:p xmlns:a="http://schemas.openxmlformats.org/drawingml/2006/main">
             <a:pPr algn="l">
+              <a:buNone/>
               <a:defRPr sz="2100" b="1">
                 <a:solidFill>
                   <a:srgbClr val="1570EF"/>
@@ -2541,6 +2554,7 @@
           <a:lstStyle xmlns:a="http://schemas.openxmlformats.org/drawingml/2006/main"/>
           <a:p xmlns:a="http://schemas.openxmlformats.org/drawingml/2006/main">
             <a:pPr algn="l">
+              <a:buNone/>
               <a:defRPr sz="1650" b="0">
                 <a:solidFill>
                   <a:srgbClr val="101828"/>
@@ -2569,6 +2583,7 @@
           </a:p>
           <a:p xmlns:a="http://schemas.openxmlformats.org/drawingml/2006/main">
             <a:pPr algn="l">
+              <a:buNone/>
               <a:defRPr sz="1650" b="0">
                 <a:solidFill>
                   <a:srgbClr val="101828"/>
@@ -2592,6 +2607,7 @@
           </a:p>
           <a:p xmlns:a="http://schemas.openxmlformats.org/drawingml/2006/main">
             <a:pPr algn="l">
+              <a:buNone/>
               <a:defRPr sz="1650" b="0">
                 <a:solidFill>
                   <a:srgbClr val="101828"/>
@@ -2615,6 +2631,7 @@
           </a:p>
           <a:p xmlns:a="http://schemas.openxmlformats.org/drawingml/2006/main">
             <a:pPr algn="l">
+              <a:buNone/>
               <a:defRPr sz="1650" b="0">
                 <a:solidFill>
                   <a:srgbClr val="101828"/>
@@ -2673,6 +2690,7 @@
           <a:lstStyle xmlns:a="http://schemas.openxmlformats.org/drawingml/2006/main"/>
           <a:p xmlns:a="http://schemas.openxmlformats.org/drawingml/2006/main">
             <a:pPr algn="l">
+              <a:buNone/>
               <a:defRPr sz="2100" b="1">
                 <a:solidFill>
                   <a:srgbClr val="067647"/>
@@ -2731,6 +2749,7 @@
           <a:lstStyle xmlns:a="http://schemas.openxmlformats.org/drawingml/2006/main"/>
           <a:p xmlns:a="http://schemas.openxmlformats.org/drawingml/2006/main">
             <a:pPr algn="l">
+              <a:buNone/>
               <a:defRPr sz="1650" b="0">
                 <a:solidFill>
                   <a:srgbClr val="101828"/>
@@ -2759,6 +2778,7 @@
           </a:p>
           <a:p xmlns:a="http://schemas.openxmlformats.org/drawingml/2006/main">
             <a:pPr algn="l">
+              <a:buNone/>
               <a:defRPr sz="1650" b="0">
                 <a:solidFill>
                   <a:srgbClr val="101828"/>
@@ -2782,6 +2802,7 @@
           </a:p>
           <a:p xmlns:a="http://schemas.openxmlformats.org/drawingml/2006/main">
             <a:pPr algn="l">
+              <a:buNone/>
               <a:defRPr sz="1650" b="0">
                 <a:solidFill>
                   <a:srgbClr val="101828"/>
@@ -2805,6 +2826,7 @@
           </a:p>
           <a:p xmlns:a="http://schemas.openxmlformats.org/drawingml/2006/main">
             <a:pPr algn="l">
+              <a:buNone/>
               <a:defRPr sz="1650" b="0">
                 <a:solidFill>
                   <a:srgbClr val="101828"/>
@@ -2863,6 +2885,7 @@
           <a:lstStyle xmlns:a="http://schemas.openxmlformats.org/drawingml/2006/main"/>
           <a:p xmlns:a="http://schemas.openxmlformats.org/drawingml/2006/main">
             <a:pPr algn="l">
+              <a:buNone/>
               <a:defRPr sz="1350" b="1">
                 <a:solidFill>
                   <a:srgbClr val="7F56D9"/>
@@ -2924,11 +2947,11 @@
           <p:nvPr/>
         </p:nvPicPr>
         <p:blipFill>
-          <a:blip xmlns:r="http://schemas.openxmlformats.org/officeDocument/2006/relationships" xmlns:a="http://schemas.openxmlformats.org/drawingml/2006/main" r:embed="R16be04d383e74f26"/>
+          <a:blip xmlns:r="http://schemas.openxmlformats.org/officeDocument/2006/relationships" xmlns:a="http://schemas.openxmlformats.org/drawingml/2006/main" r:embed="Rb1e4fe6b44e74c74"/>
           <a:stretch xmlns:a="http://schemas.openxmlformats.org/drawingml/2006/main"/>
         </p:blipFill>
         <p:spPr>
-          <a:xfrm xmlns:a="http://schemas.openxmlformats.org/drawingml/2006/main">
+          <a:xfrm xmlns:a="http://schemas.openxmlformats.org/drawingml/2006/main" flipH="0" flipV="0">
             <a:off x="449179" y="76200"/>
             <a:ext cx="11293642" cy="6705600"/>
           </a:xfrm>
@@ -3001,6 +3024,7 @@
           <a:lstStyle xmlns:a="http://schemas.openxmlformats.org/drawingml/2006/main"/>
           <a:p xmlns:a="http://schemas.openxmlformats.org/drawingml/2006/main">
             <a:pPr algn="l">
+              <a:buNone/>
               <a:defRPr sz="1125" b="1">
                 <a:solidFill>
                   <a:srgbClr val="1570EF"/>
@@ -3059,6 +3083,7 @@
           <a:lstStyle xmlns:a="http://schemas.openxmlformats.org/drawingml/2006/main"/>
           <a:p xmlns:a="http://schemas.openxmlformats.org/drawingml/2006/main">
             <a:pPr algn="l">
+              <a:buNone/>
               <a:defRPr sz="2850" b="1">
                 <a:solidFill>
                   <a:srgbClr val="101828"/>
@@ -3148,6 +3173,7 @@
           <a:lstStyle xmlns:a="http://schemas.openxmlformats.org/drawingml/2006/main"/>
           <a:p xmlns:a="http://schemas.openxmlformats.org/drawingml/2006/main">
             <a:pPr algn="r">
+              <a:buNone/>
               <a:defRPr sz="900" b="0">
                 <a:solidFill>
                   <a:srgbClr val="667085"/>
@@ -3206,6 +3232,7 @@
           <a:lstStyle xmlns:a="http://schemas.openxmlformats.org/drawingml/2006/main"/>
           <a:p xmlns:a="http://schemas.openxmlformats.org/drawingml/2006/main">
             <a:pPr algn="l">
+              <a:buNone/>
               <a:defRPr sz="2100" b="1">
                 <a:solidFill>
                   <a:srgbClr val="1570EF"/>
@@ -3295,6 +3322,7 @@
           <a:lstStyle xmlns:a="http://schemas.openxmlformats.org/drawingml/2006/main"/>
           <a:p xmlns:a="http://schemas.openxmlformats.org/drawingml/2006/main">
             <a:pPr algn="l">
+              <a:buNone/>
               <a:defRPr sz="1575" b="0">
                 <a:solidFill>
                   <a:srgbClr val="101828"/>
@@ -3323,6 +3351,7 @@
           </a:p>
           <a:p xmlns:a="http://schemas.openxmlformats.org/drawingml/2006/main">
             <a:pPr algn="l">
+              <a:buNone/>
               <a:defRPr sz="1575" b="0">
                 <a:solidFill>
                   <a:srgbClr val="101828"/>
@@ -3381,6 +3410,7 @@
           <a:lstStyle xmlns:a="http://schemas.openxmlformats.org/drawingml/2006/main"/>
           <a:p xmlns:a="http://schemas.openxmlformats.org/drawingml/2006/main">
             <a:pPr algn="l">
+              <a:buNone/>
               <a:defRPr sz="2100" b="1">
                 <a:solidFill>
                   <a:srgbClr val="7F56D9"/>
@@ -3470,6 +3500,7 @@
           <a:lstStyle xmlns:a="http://schemas.openxmlformats.org/drawingml/2006/main"/>
           <a:p xmlns:a="http://schemas.openxmlformats.org/drawingml/2006/main">
             <a:pPr algn="l">
+              <a:buNone/>
               <a:defRPr sz="1575" b="0">
                 <a:solidFill>
                   <a:srgbClr val="101828"/>
@@ -3498,6 +3529,7 @@
           </a:p>
           <a:p xmlns:a="http://schemas.openxmlformats.org/drawingml/2006/main">
             <a:pPr algn="l">
+              <a:buNone/>
               <a:defRPr sz="1575" b="0">
                 <a:solidFill>
                   <a:srgbClr val="101828"/>
@@ -3556,6 +3588,7 @@
           <a:lstStyle xmlns:a="http://schemas.openxmlformats.org/drawingml/2006/main"/>
           <a:p xmlns:a="http://schemas.openxmlformats.org/drawingml/2006/main">
             <a:pPr algn="l">
+              <a:buNone/>
               <a:defRPr sz="2100" b="1">
                 <a:solidFill>
                   <a:srgbClr val="067647"/>
@@ -3645,6 +3678,7 @@
           <a:lstStyle xmlns:a="http://schemas.openxmlformats.org/drawingml/2006/main"/>
           <a:p xmlns:a="http://schemas.openxmlformats.org/drawingml/2006/main">
             <a:pPr algn="l">
+              <a:buNone/>
               <a:defRPr sz="1575" b="0">
                 <a:solidFill>
                   <a:srgbClr val="101828"/>
@@ -3673,6 +3707,7 @@
           </a:p>
           <a:p xmlns:a="http://schemas.openxmlformats.org/drawingml/2006/main">
             <a:pPr algn="l">
+              <a:buNone/>
               <a:defRPr sz="1575" b="0">
                 <a:solidFill>
                   <a:srgbClr val="101828"/>
@@ -3731,6 +3766,7 @@
           <a:lstStyle xmlns:a="http://schemas.openxmlformats.org/drawingml/2006/main"/>
           <a:p xmlns:a="http://schemas.openxmlformats.org/drawingml/2006/main">
             <a:pPr algn="l">
+              <a:buNone/>
               <a:defRPr sz="1425" b="0">
                 <a:solidFill>
                   <a:srgbClr val="667085"/>
@@ -3818,6 +3854,7 @@
           <a:lstStyle xmlns:a="http://schemas.openxmlformats.org/drawingml/2006/main"/>
           <a:p xmlns:a="http://schemas.openxmlformats.org/drawingml/2006/main">
             <a:pPr algn="l">
+              <a:buNone/>
               <a:defRPr sz="1125" b="1">
                 <a:solidFill>
                   <a:srgbClr val="1570EF"/>
@@ -3876,6 +3913,7 @@
           <a:lstStyle xmlns:a="http://schemas.openxmlformats.org/drawingml/2006/main"/>
           <a:p xmlns:a="http://schemas.openxmlformats.org/drawingml/2006/main">
             <a:pPr algn="l">
+              <a:buNone/>
               <a:defRPr sz="2850" b="1">
                 <a:solidFill>
                   <a:srgbClr val="101828"/>
@@ -3894,7 +3932,7 @@
                 <a:ea typeface="Apple SD Gothic Neo"/>
                 <a:cs typeface="Apple SD Gothic Neo"/>
               </a:rPr>
-              <a:t>실제 거래 427건이 최종 1분봉 3건으로 저장됐습니다</a:t>
+              <a:t>실제 거래 427건 발행 후, 174건이 확정 봉 3건에 반영됐습니다</a:t>
             </a:r>
           </a:p>
         </p:txBody>
@@ -3965,6 +4003,7 @@
           <a:lstStyle xmlns:a="http://schemas.openxmlformats.org/drawingml/2006/main"/>
           <a:p xmlns:a="http://schemas.openxmlformats.org/drawingml/2006/main">
             <a:pPr algn="r">
+              <a:buNone/>
               <a:defRPr sz="900" b="0">
                 <a:solidFill>
                   <a:srgbClr val="667085"/>
@@ -4023,6 +4062,7 @@
           <a:lstStyle xmlns:a="http://schemas.openxmlformats.org/drawingml/2006/main"/>
           <a:p xmlns:a="http://schemas.openxmlformats.org/drawingml/2006/main">
             <a:pPr algn="l">
+              <a:buNone/>
               <a:defRPr sz="1500" b="0">
                 <a:solidFill>
                   <a:srgbClr val="667085"/>
@@ -4143,6 +4183,7 @@
           <a:lstStyle xmlns:a="http://schemas.openxmlformats.org/drawingml/2006/main"/>
           <a:p xmlns:a="http://schemas.openxmlformats.org/drawingml/2006/main">
             <a:pPr algn="l">
+              <a:buNone/>
               <a:defRPr sz="4050" b="1">
                 <a:solidFill>
                   <a:srgbClr val="101828"/>
@@ -4201,6 +4242,7 @@
           <a:lstStyle xmlns:a="http://schemas.openxmlformats.org/drawingml/2006/main"/>
           <a:p xmlns:a="http://schemas.openxmlformats.org/drawingml/2006/main">
             <a:pPr algn="l">
+              <a:buNone/>
               <a:defRPr sz="1725" b="1">
                 <a:solidFill>
                   <a:srgbClr val="101828"/>
@@ -4259,6 +4301,7 @@
           <a:lstStyle xmlns:a="http://schemas.openxmlformats.org/drawingml/2006/main"/>
           <a:p xmlns:a="http://schemas.openxmlformats.org/drawingml/2006/main">
             <a:pPr algn="l">
+              <a:buNone/>
               <a:defRPr sz="1275" b="0">
                 <a:solidFill>
                   <a:srgbClr val="667085"/>
@@ -4379,6 +4422,7 @@
           <a:lstStyle xmlns:a="http://schemas.openxmlformats.org/drawingml/2006/main"/>
           <a:p xmlns:a="http://schemas.openxmlformats.org/drawingml/2006/main">
             <a:pPr algn="l">
+              <a:buNone/>
               <a:defRPr sz="4050" b="1">
                 <a:solidFill>
                   <a:srgbClr val="101828"/>
@@ -4437,6 +4481,7 @@
           <a:lstStyle xmlns:a="http://schemas.openxmlformats.org/drawingml/2006/main"/>
           <a:p xmlns:a="http://schemas.openxmlformats.org/drawingml/2006/main">
             <a:pPr algn="l">
+              <a:buNone/>
               <a:defRPr sz="1725" b="1">
                 <a:solidFill>
                   <a:srgbClr val="101828"/>
@@ -4495,6 +4540,7 @@
           <a:lstStyle xmlns:a="http://schemas.openxmlformats.org/drawingml/2006/main"/>
           <a:p xmlns:a="http://schemas.openxmlformats.org/drawingml/2006/main">
             <a:pPr algn="l">
+              <a:buNone/>
               <a:defRPr sz="1275" b="0">
                 <a:solidFill>
                   <a:srgbClr val="667085"/>
@@ -4615,6 +4661,7 @@
           <a:lstStyle xmlns:a="http://schemas.openxmlformats.org/drawingml/2006/main"/>
           <a:p xmlns:a="http://schemas.openxmlformats.org/drawingml/2006/main">
             <a:pPr algn="l">
+              <a:buNone/>
               <a:defRPr sz="4050" b="1">
                 <a:solidFill>
                   <a:srgbClr val="101828"/>
@@ -4673,6 +4720,7 @@
           <a:lstStyle xmlns:a="http://schemas.openxmlformats.org/drawingml/2006/main"/>
           <a:p xmlns:a="http://schemas.openxmlformats.org/drawingml/2006/main">
             <a:pPr algn="l">
+              <a:buNone/>
               <a:defRPr sz="1725" b="1">
                 <a:solidFill>
                   <a:srgbClr val="101828"/>
@@ -4731,6 +4779,7 @@
           <a:lstStyle xmlns:a="http://schemas.openxmlformats.org/drawingml/2006/main"/>
           <a:p xmlns:a="http://schemas.openxmlformats.org/drawingml/2006/main">
             <a:pPr algn="l">
+              <a:buNone/>
               <a:defRPr sz="1275" b="0">
                 <a:solidFill>
                   <a:srgbClr val="667085"/>
@@ -4789,6 +4838,7 @@
           <a:lstStyle xmlns:a="http://schemas.openxmlformats.org/drawingml/2006/main"/>
           <a:p xmlns:a="http://schemas.openxmlformats.org/drawingml/2006/main">
             <a:pPr algn="l">
+              <a:buNone/>
               <a:defRPr sz="1425" b="1">
                 <a:solidFill>
                   <a:srgbClr val="101828"/>
@@ -4807,7 +4857,7 @@
                 <a:ea typeface="Apple SD Gothic Neo"/>
                 <a:cs typeface="Apple SD Gothic Neo"/>
               </a:rPr>
-              <a:t>끝부분 봉은 2분 watermark가 진행되기 전이라 미확정 상태로 남겼습니다. 데이터 손실이 아닙니다.</a:t>
+              <a:t>나머지 구간은 실행 종료 시 watermark를 통과하지 않아 final row로 저장되지 않았습니다.</a:t>
             </a:r>
           </a:p>
         </p:txBody>
@@ -4876,6 +4926,7 @@
           <a:lstStyle xmlns:a="http://schemas.openxmlformats.org/drawingml/2006/main"/>
           <a:p xmlns:a="http://schemas.openxmlformats.org/drawingml/2006/main">
             <a:pPr algn="l">
+              <a:buNone/>
               <a:defRPr sz="1125" b="1">
                 <a:solidFill>
                   <a:srgbClr val="1570EF"/>
@@ -4934,6 +4985,7 @@
           <a:lstStyle xmlns:a="http://schemas.openxmlformats.org/drawingml/2006/main"/>
           <a:p xmlns:a="http://schemas.openxmlformats.org/drawingml/2006/main">
             <a:pPr algn="l">
+              <a:buNone/>
               <a:defRPr sz="2850" b="1">
                 <a:solidFill>
                   <a:srgbClr val="101828"/>
@@ -5023,6 +5075,7 @@
           <a:lstStyle xmlns:a="http://schemas.openxmlformats.org/drawingml/2006/main"/>
           <a:p xmlns:a="http://schemas.openxmlformats.org/drawingml/2006/main">
             <a:pPr algn="r">
+              <a:buNone/>
               <a:defRPr sz="900" b="0">
                 <a:solidFill>
                   <a:srgbClr val="667085"/>
@@ -5048,14 +5101,14 @@
       </p:sp>
       <p:pic>
         <p:nvPicPr>
-          <p:cNvPr id="14" name=""/>
+          <p:cNvPr id="17" name=""/>
           <p:cNvPicPr>
             <a:picLocks xmlns:a="http://schemas.openxmlformats.org/drawingml/2006/main" noChangeAspect="1"/>
           </p:cNvPicPr>
           <p:nvPr/>
         </p:nvPicPr>
         <p:blipFill>
-          <a:blip xmlns:r="http://schemas.openxmlformats.org/officeDocument/2006/relationships" xmlns:a="http://schemas.openxmlformats.org/drawingml/2006/main" r:embed="Ra37be132f364426e"/>
+          <a:blip xmlns:r="http://schemas.openxmlformats.org/officeDocument/2006/relationships" xmlns:a="http://schemas.openxmlformats.org/drawingml/2006/main" r:embed="R93661cf571624f23"/>
           <a:stretch xmlns:a="http://schemas.openxmlformats.org/drawingml/2006/main"/>
         </p:blipFill>
         <p:spPr>
@@ -5070,14 +5123,14 @@
       </p:pic>
       <p:pic>
         <p:nvPicPr>
-          <p:cNvPr id="15" name=""/>
+          <p:cNvPr id="18" name=""/>
           <p:cNvPicPr>
             <a:picLocks xmlns:a="http://schemas.openxmlformats.org/drawingml/2006/main" noChangeAspect="1"/>
           </p:cNvPicPr>
           <p:nvPr/>
         </p:nvPicPr>
         <p:blipFill>
-          <a:blip xmlns:r="http://schemas.openxmlformats.org/officeDocument/2006/relationships" xmlns:a="http://schemas.openxmlformats.org/drawingml/2006/main" r:embed="R848e8671080e4811"/>
+          <a:blip xmlns:r="http://schemas.openxmlformats.org/officeDocument/2006/relationships" xmlns:a="http://schemas.openxmlformats.org/drawingml/2006/main" r:embed="R0bce8c6a7ccf423a"/>
           <a:stretch xmlns:a="http://schemas.openxmlformats.org/drawingml/2006/main"/>
         </p:blipFill>
         <p:spPr>
@@ -5125,6 +5178,7 @@
           <a:lstStyle xmlns:a="http://schemas.openxmlformats.org/drawingml/2006/main"/>
           <a:p xmlns:a="http://schemas.openxmlformats.org/drawingml/2006/main">
             <a:pPr algn="l">
+              <a:buNone/>
               <a:defRPr sz="1650" b="1">
                 <a:solidFill>
                   <a:srgbClr val="101828"/>
@@ -5183,6 +5237,7 @@
           <a:lstStyle xmlns:a="http://schemas.openxmlformats.org/drawingml/2006/main"/>
           <a:p xmlns:a="http://schemas.openxmlformats.org/drawingml/2006/main">
             <a:pPr algn="l">
+              <a:buNone/>
               <a:defRPr sz="1650" b="1">
                 <a:solidFill>
                   <a:srgbClr val="101828"/>
@@ -5241,6 +5296,7 @@
           <a:lstStyle xmlns:a="http://schemas.openxmlformats.org/drawingml/2006/main"/>
           <a:p xmlns:a="http://schemas.openxmlformats.org/drawingml/2006/main">
             <a:pPr algn="l">
+              <a:buNone/>
               <a:defRPr sz="1350" b="0">
                 <a:solidFill>
                   <a:srgbClr val="667085"/>
@@ -5328,6 +5384,7 @@
           <a:lstStyle xmlns:a="http://schemas.openxmlformats.org/drawingml/2006/main"/>
           <a:p xmlns:a="http://schemas.openxmlformats.org/drawingml/2006/main">
             <a:pPr algn="l">
+              <a:buNone/>
               <a:defRPr sz="1200" b="1">
                 <a:solidFill>
                   <a:srgbClr val="1570EF"/>
@@ -5386,6 +5443,7 @@
           <a:lstStyle xmlns:a="http://schemas.openxmlformats.org/drawingml/2006/main"/>
           <a:p xmlns:a="http://schemas.openxmlformats.org/drawingml/2006/main">
             <a:pPr algn="l">
+              <a:buNone/>
               <a:defRPr sz="4050" b="1">
                 <a:solidFill>
                   <a:srgbClr val="101828"/>
@@ -5409,6 +5467,7 @@
           </a:p>
           <a:p xmlns:a="http://schemas.openxmlformats.org/drawingml/2006/main">
             <a:pPr algn="l">
+              <a:buNone/>
               <a:defRPr sz="4050" b="1">
                 <a:solidFill>
                   <a:srgbClr val="101828"/>
@@ -5467,6 +5526,7 @@
           <a:lstStyle xmlns:a="http://schemas.openxmlformats.org/drawingml/2006/main"/>
           <a:p xmlns:a="http://schemas.openxmlformats.org/drawingml/2006/main">
             <a:pPr algn="l">
+              <a:buNone/>
               <a:defRPr sz="1875" b="1">
                 <a:solidFill>
                   <a:srgbClr val="067647"/>
@@ -5525,6 +5585,7 @@
           <a:lstStyle xmlns:a="http://schemas.openxmlformats.org/drawingml/2006/main"/>
           <a:p xmlns:a="http://schemas.openxmlformats.org/drawingml/2006/main">
             <a:pPr algn="l">
+              <a:buNone/>
               <a:defRPr sz="1575" b="0">
                 <a:solidFill>
                   <a:srgbClr val="101828"/>
@@ -5548,6 +5609,7 @@
           </a:p>
           <a:p xmlns:a="http://schemas.openxmlformats.org/drawingml/2006/main">
             <a:pPr algn="l">
+              <a:buNone/>
               <a:defRPr sz="1575" b="0">
                 <a:solidFill>
                   <a:srgbClr val="101828"/>
@@ -5606,6 +5668,7 @@
           <a:lstStyle xmlns:a="http://schemas.openxmlformats.org/drawingml/2006/main"/>
           <a:p xmlns:a="http://schemas.openxmlformats.org/drawingml/2006/main">
             <a:pPr algn="l">
+              <a:buNone/>
               <a:defRPr sz="1875" b="1">
                 <a:solidFill>
                   <a:srgbClr val="7F56D9"/>
@@ -5664,6 +5727,7 @@
           <a:lstStyle xmlns:a="http://schemas.openxmlformats.org/drawingml/2006/main"/>
           <a:p xmlns:a="http://schemas.openxmlformats.org/drawingml/2006/main">
             <a:pPr algn="l">
+              <a:buNone/>
               <a:defRPr sz="1575" b="0">
                 <a:solidFill>
                   <a:srgbClr val="101828"/>
@@ -5687,6 +5751,7 @@
           </a:p>
           <a:p xmlns:a="http://schemas.openxmlformats.org/drawingml/2006/main">
             <a:pPr algn="l">
+              <a:buNone/>
               <a:defRPr sz="1575" b="0">
                 <a:solidFill>
                   <a:srgbClr val="101828"/>
@@ -5776,6 +5841,7 @@
           <a:lstStyle xmlns:a="http://schemas.openxmlformats.org/drawingml/2006/main"/>
           <a:p xmlns:a="http://schemas.openxmlformats.org/drawingml/2006/main">
             <a:pPr algn="l">
+              <a:buNone/>
               <a:defRPr sz="1500" b="1">
                 <a:solidFill>
                   <a:srgbClr val="1570EF"/>
@@ -5834,6 +5900,7 @@
           <a:lstStyle xmlns:a="http://schemas.openxmlformats.org/drawingml/2006/main"/>
           <a:p xmlns:a="http://schemas.openxmlformats.org/drawingml/2006/main">
             <a:pPr algn="r">
+              <a:buNone/>
               <a:defRPr sz="900" b="0">
                 <a:solidFill>
                   <a:srgbClr val="667085"/>

</xml_diff>

<commit_message>
feat: build CPI event study and finalize Kafka Spark assignment
</commit_message>
<xml_diff>
--- a/docs/presentation/us-market-pipeline-assignment.pptx
+++ b/docs/presentation/us-market-pipeline-assignment.pptx
@@ -2,19 +2,19 @@
 <file path=ppt/presentation.xml><?xml version="1.0" encoding="utf-8"?>
 <p:presentation xmlns:p="http://schemas.openxmlformats.org/presentationml/2006/main">
   <p:sldMasterIdLst>
-    <p:sldMasterId xmlns:r="http://schemas.openxmlformats.org/officeDocument/2006/relationships" id="2147483648" r:id="R3c74cbf8fd404a93"/>
+    <p:sldMasterId xmlns:r="http://schemas.openxmlformats.org/officeDocument/2006/relationships" id="2147483648" r:id="R8b1db6b6e43545ae"/>
   </p:sldMasterIdLst>
   <p:notesMasterIdLst>
-    <p:notesMasterId xmlns:r="http://schemas.openxmlformats.org/officeDocument/2006/relationships" r:id="R9df53b7480dd4a7d"/>
+    <p:notesMasterId xmlns:r="http://schemas.openxmlformats.org/officeDocument/2006/relationships" r:id="R5f6122255568499c"/>
   </p:notesMasterIdLst>
   <p:sldIdLst>
-    <p:sldId xmlns:r="http://schemas.openxmlformats.org/officeDocument/2006/relationships" id="256" r:id="Rf1de833356e14f92"/>
-    <p:sldId xmlns:r="http://schemas.openxmlformats.org/officeDocument/2006/relationships" id="257" r:id="R7b4c4d1584c64295"/>
-    <p:sldId xmlns:r="http://schemas.openxmlformats.org/officeDocument/2006/relationships" id="258" r:id="R1b59cbfa43db4b6f"/>
-    <p:sldId xmlns:r="http://schemas.openxmlformats.org/officeDocument/2006/relationships" id="259" r:id="Rc436f709230f471c"/>
-    <p:sldId xmlns:r="http://schemas.openxmlformats.org/officeDocument/2006/relationships" id="260" r:id="Rc1d26bd2fd3d4a8f"/>
-    <p:sldId xmlns:r="http://schemas.openxmlformats.org/officeDocument/2006/relationships" id="261" r:id="R67335da551194e20"/>
-    <p:sldId xmlns:r="http://schemas.openxmlformats.org/officeDocument/2006/relationships" id="262" r:id="R1eef359c5a3b4bfa"/>
+    <p:sldId xmlns:r="http://schemas.openxmlformats.org/officeDocument/2006/relationships" id="256" r:id="Rc8fc4f1df33049e0"/>
+    <p:sldId xmlns:r="http://schemas.openxmlformats.org/officeDocument/2006/relationships" id="257" r:id="R9ea472c6c39342dc"/>
+    <p:sldId xmlns:r="http://schemas.openxmlformats.org/officeDocument/2006/relationships" id="258" r:id="Rc16c077b62764a3b"/>
+    <p:sldId xmlns:r="http://schemas.openxmlformats.org/officeDocument/2006/relationships" id="259" r:id="Rc5687a7a8f8642e7"/>
+    <p:sldId xmlns:r="http://schemas.openxmlformats.org/officeDocument/2006/relationships" id="260" r:id="Re667162faf924031"/>
+    <p:sldId xmlns:r="http://schemas.openxmlformats.org/officeDocument/2006/relationships" id="261" r:id="R1571352f88b346f5"/>
+    <p:sldId xmlns:r="http://schemas.openxmlformats.org/officeDocument/2006/relationships" id="262" r:id="R19de9f576f434b0b"/>
   </p:sldIdLst>
   <p:sldSz cx="12192000" cy="6858000"/>
   <p:notesSz cx="6858000" cy="9144000"/>
@@ -448,7 +448,7 @@
           <a:lstStyle xmlns:a="http://schemas.openxmlformats.org/drawingml/2006/main"/>
           <a:p xmlns:a="http://schemas.openxmlformats.org/drawingml/2006/main">
             <a:r>
-              <a:t>안녕하세요. 저는 실제 미국 주식 거래 데이터를 받아서 1분봉으로 가공하고 저장하는 파이프라인을 만들고 있습니다. 이번 과제에서는 분석이나 자동매매까지 넓히지 않고, 실제 데이터가 들어와 저장되는 뼈대까지 구현했습니다. 화면에 보이는 Kafka와 PostgreSQL은 실제로 실행 가능한 상태입니다.</a:t>
+              <a:t>안녕하세요. 제 프로젝트는 실제 미국 주식 거래 데이터를 수집해서 1분봉으로 저장하는 데이터 파이프라인입니다. 최종적으로는 CPI, 고용, 금리 같은 경제지표 발표 전후에 주가와 거래량, 변동성이 어떻게 달라졌는지 검증하려고 합니다. 이번 과제에서는 분석이나 주문 기능보다 실제 데이터가 수집되고 처리되고 저장되는 전체 흐름에 집중했습니다.</a:t>
             </a:r>
           </a:p>
           <a:p xmlns:a="http://schemas.openxmlformats.org/drawingml/2006/main">
@@ -468,7 +468,7 @@
           </a:p>
           <a:p xmlns:a="http://schemas.openxmlformats.org/drawingml/2006/main">
             <a:r>
-              <a:t>- /Users/hanjeonghyun/dev/2026/for_my_stock/docs/evidence/presentation-captures/01_services_and_raw_storage.png</a:t>
+              <a:t>- /Users/hanjeonghyun/dev/2026/for_my_stock/docs/final-vision.md</a:t>
             </a:r>
           </a:p>
           <a:p xmlns:a="http://schemas.openxmlformats.org/drawingml/2006/main">
@@ -543,7 +543,7 @@
           <a:lstStyle xmlns:a="http://schemas.openxmlformats.org/drawingml/2006/main"/>
           <a:p xmlns:a="http://schemas.openxmlformats.org/drawingml/2006/main">
             <a:r>
-              <a:t>데이터 소스는 두 가지입니다. 장중에는 Alpaca IEX WebSocket으로 실시간 거래를 받고, 장이 끝난 뒤에는 Historical Trades API로 같은 형식의 실제 거래를 다시 가져옵니다. 이렇게 하면 실시간성을 확인하면서도 발표나 테스트 때 같은 구간을 재현할 수 있습니다. 다만 무료 IEX는 미국 전체 거래소 데이터가 아니기 때문에 전체 시장 거래량이라고 단정하지 않습니다.</a:t>
+              <a:t>주식 데이터는 Alpaca에서 가져옵니다. WebSocket에서는 SPY, QQQ, NVDA 실제 거래 10건을 Kafka까지 확인했습니다. 같은 처리를 다시 확인하기 위해 Historical API에서 SMH의 2026년 8월 19일 19시 50분부터 19시 56분까지 실제 거래도 가져왔습니다. 다음 단계에서는 BLS, BEA, 연준의 공식 경제지표를 FRED와 ALFRED의 시계열 및 당시 공개 값과 함께 수집할 계획입니다. 경제지표 수집은 아직 구현 전입니다.</a:t>
             </a:r>
           </a:p>
           <a:p xmlns:a="http://schemas.openxmlformats.org/drawingml/2006/main">
@@ -569,6 +569,11 @@
           <a:p xmlns:a="http://schemas.openxmlformats.org/drawingml/2006/main">
             <a:r>
               <a:t>- /Users/hanjeonghyun/dev/2026/for_my_stock/docs/data-source-catalog.md</a:t>
+            </a:r>
+          </a:p>
+          <a:p xmlns:a="http://schemas.openxmlformats.org/drawingml/2006/main">
+            <a:r>
+              <a:t>- /Users/hanjeonghyun/dev/2026/for_my_stock/docs/test-results/2026-08-19-kafka-producer-smoke.md</a:t>
             </a:r>
           </a:p>
           <a:p xmlns:a="http://schemas.openxmlformats.org/drawingml/2006/main">
@@ -643,7 +648,7 @@
           <a:lstStyle xmlns:a="http://schemas.openxmlformats.org/drawingml/2006/main"/>
           <a:p xmlns:a="http://schemas.openxmlformats.org/drawingml/2006/main">
             <a:r>
-              <a:t>전체 흐름은 왼쪽에서 오른쪽입니다. Alpaca에서 받은 거래를 Python이 공통 형식으로 감싸고, Kafka가 원본 이벤트를 24시간 보관합니다. Spark는 거래가 실제로 발생한 시각을 기준으로 1분 OHLCV를 만들고, PostgreSQL에는 확정된 봉만 저장합니다. 파란색과 초록색 실선이 이번에 구현한 범위이고, 보라색 점선은 다음 단계인 경제지표 수집과 분석입니다.</a:t>
+              <a:t>현재 흐름은 Alpaca, Python 수집기, Kafka, Spark, PostgreSQL 순서입니다. Kafka는 원본 거래를 24시간 보관하고, Spark는 개별 거래를 1분 단위로 묶어 OHLCV와 거래 건수, VWAP을 계산합니다. 완성된 1분봉은 PostgreSQL에 저장합니다. 그림 아래쪽의 경제지표 수집과 Airflow 배치, 분석 화면은 앞으로 구현할 부분입니다.</a:t>
             </a:r>
           </a:p>
           <a:p xmlns:a="http://schemas.openxmlformats.org/drawingml/2006/main">
@@ -663,12 +668,7 @@
           </a:p>
           <a:p xmlns:a="http://schemas.openxmlformats.org/drawingml/2006/main">
             <a:r>
-              <a:t>- https://docs.aws.amazon.com/wellarchitected/latest/analytics-lens/reference-architecture-2.html</a:t>
-            </a:r>
-          </a:p>
-          <a:p xmlns:a="http://schemas.openxmlformats.org/drawingml/2006/main">
-            <a:r>
-              <a:t>- https://docs.databricks.com/aws/en/lakehouse/medallion</a:t>
+              <a:t>- /Users/hanjeonghyun/dev/2026/for_my_stock/docs/architecture.md</a:t>
             </a:r>
           </a:p>
           <a:p xmlns:a="http://schemas.openxmlformats.org/drawingml/2006/main">
@@ -743,7 +743,7 @@
           <a:lstStyle xmlns:a="http://schemas.openxmlformats.org/drawingml/2006/main"/>
           <a:p xmlns:a="http://schemas.openxmlformats.org/drawingml/2006/main">
             <a:r>
-              <a:t>Kafka는 단순히 많이 받기 위해서가 아니라 수집과 처리를 분리하고 원본을 다시 읽기 위해 사용했습니다. Spark는 늦게 도착하거나 순서가 바뀐 거래를 실제 거래 시각으로 묶는 역할입니다. PostgreSQL은 최종 1분봉을 SQL로 확인하고, 같은 데이터를 다시 처리해도 한 번만 남도록 합니다. 현재 규모에서 Spark가 꼭 필요한지는 이후 부하 테스트로 따로 검증할 계획입니다.</a:t>
+              <a:t>Kafka는 수집과 처리를 분리하고 장애가 생겨도 원본 데이터를 다시 읽기 위해 사용했습니다. Spark는 실제 거래 시각 기준의 1분 집계와 중복·지연 데이터 처리를 맡습니다. 현재 규모에는 큰 기술일 수 있어 이후 부하 테스트로 사용 근거를 확인할 계획입니다. PostgreSQL은 최종 결과를 SQL로 조회하고 중복 없이 저장하기 위해 선택했습니다. Airflow는 경제지표와 과거 데이터 배치에 사용할 예정입니다.</a:t>
             </a:r>
           </a:p>
           <a:p xmlns:a="http://schemas.openxmlformats.org/drawingml/2006/main">
@@ -838,7 +838,7 @@
           <a:lstStyle xmlns:a="http://schemas.openxmlformats.org/drawingml/2006/main"/>
           <a:p xmlns:a="http://schemas.openxmlformats.org/drawingml/2006/main">
             <a:r>
-              <a:t>실제 결과입니다. SMH 거래 427건을 API에서 가져와 Kafka에 모두 발행했습니다. 이 실행 종료 시점에는 그중 174건이 watermark를 통과한 확정 1분봉 3건에 반영됐고, business key 중복은 0건입니다. 나머지 구간은 아직 final row로 저장되지 않았으며 checkpoint를 유지하고 event-time이 진행되면 확정될 수 있습니다.</a:t>
+              <a:t>Historical API에서 SMH 실제 거래 427건을 가져와 Kafka에 모두 발행했습니다. 실행 종료 전에 watermark를 통과한 거래 174건이 PostgreSQL의 확정 1분봉 3건에 반영됐고 중복 키는 0건이었습니다. 나머지 거래는 종료 시점에 아직 watermark를 통과하지 않아 final row로 저장되지 않았습니다. WebSocket 실제 거래 10건은 Kafka까지 확인했고 PostgreSQL까지의 실시간 전체 경로는 아직 검증 전입니다.</a:t>
             </a:r>
           </a:p>
           <a:p xmlns:a="http://schemas.openxmlformats.org/drawingml/2006/main">
@@ -933,7 +933,7 @@
           <a:lstStyle xmlns:a="http://schemas.openxmlformats.org/drawingml/2006/main"/>
           <a:p xmlns:a="http://schemas.openxmlformats.org/drawingml/2006/main">
             <a:r>
-              <a:t>정상 결과만 확인하지 않았습니다. 단위 테스트 45개를 다시 통과했고, 실제 Kafka와 Spark checkpoint를 사용하는 통합 테스트도 2개 통과했습니다. DB가 내려간 동안에는 성공으로 처리하지 않고 명시적으로 실패했고, 복구한 뒤 같은 batch를 다시 실행했을 때 중복 없이 한 건만 남았습니다. 공개 캡처에는 키와 연결 문자열, 원본 데이터는 넣지 않았습니다.</a:t>
+              <a:t>자동 테스트 45개와 Kafka·Spark 통합 테스트 2개를 통과했습니다. 늦게 도착한 데이터와 중복 데이터 처리, Spark 재시작, PostgreSQL 장애 후 재처리도 확인했습니다. API 키와 실제 원본 데이터는 GitHub에 올리지 않았습니다.</a:t>
             </a:r>
           </a:p>
           <a:p xmlns:a="http://schemas.openxmlformats.org/drawingml/2006/main">
@@ -1033,7 +1033,7 @@
           <a:lstStyle xmlns:a="http://schemas.openxmlformats.org/drawingml/2006/main"/>
           <a:p xmlns:a="http://schemas.openxmlformats.org/drawingml/2006/main">
             <a:r>
-              <a:t>정리하면 이번 과제의 필수 범위인 실제 데이터 수집부터 저장까지는 완료했습니다. 다음 미국 정규장에는 WebSocket에서 PostgreSQL까지 한 번에 실행한 증거를 추가하겠습니다. 그다음 FRED와 공식 경제지표 발표 시각을 연결해서 발표 전후 주가 반응을 반복 비교할 계획입니다. 멘토님께는 현재 IEX 범위와 이 규모에서 Spark를 사용하는 근거가 적절한지 피드백을 받고 싶습니다.</a:t>
+              <a:t>이번 과제에서는 전체 아키텍처를 그리고 실제 데이터를 수집해 PostgreSQL에 저장하는 단계까지 완료했습니다. 다음에는 정규장에 WebSocket부터 PostgreSQL까지 전체 경로를 검증하겠습니다. 이후 공식 경제지표를 추가해 발표 전후 5분, 30분, 60분 동안 가격과 거래량, 변동성이 어떻게 달라졌는지 비교할 계획입니다. 멘토님께는 현재 검증 규모의 Spark 사용 근거와 Kafka의 24시간 보관 정책이 적절한지 피드백을 받고 싶습니다.</a:t>
             </a:r>
           </a:p>
           <a:p xmlns:a="http://schemas.openxmlformats.org/drawingml/2006/main">
@@ -1126,7 +1126,7 @@
   </p:cSld>
   <p:clrMap bg1="lt1" tx1="dk1" bg2="lt2" tx2="dk2" accent1="accent1" accent2="accent2" accent3="accent3" accent4="accent4" accent5="accent5" accent6="accent6" hlink="hlink" folHlink="folHlink"/>
   <p:sldLayoutIdLst>
-    <p:sldLayoutId xmlns:r="http://schemas.openxmlformats.org/officeDocument/2006/relationships" id="2147483649" r:id="R096cee767e0d4281"/>
+    <p:sldLayoutId xmlns:r="http://schemas.openxmlformats.org/officeDocument/2006/relationships" id="2147483649" r:id="R2dd27509997c47c7"/>
   </p:sldLayoutIdLst>
   <p:txStyles>
     <p:titleStyle>
@@ -1927,7 +1927,8 @@
                 <a:ea typeface="Apple SD Gothic Neo"/>
                 <a:cs typeface="Apple SD Gothic Neo"/>
               </a:rPr>
-              <a:t>이번 범위: 실제 데이터 소스 → Ingestion → Data Storage</a:t>
+              <a:t>최종 목표: 경제지표 발표 전후 시장 반응 검증
+이번 범위: 실제 데이터 → Ingestion → Data Storage</a:t>
             </a:r>
           </a:p>
         </p:txBody>
@@ -2033,7 +2034,7 @@
           <p:nvPr/>
         </p:nvPicPr>
         <p:blipFill>
-          <a:blip xmlns:r="http://schemas.openxmlformats.org/officeDocument/2006/relationships" xmlns:a="http://schemas.openxmlformats.org/drawingml/2006/main" r:embed="Reb4adf7d90a04c5f"/>
+          <a:blip xmlns:r="http://schemas.openxmlformats.org/officeDocument/2006/relationships" xmlns:a="http://schemas.openxmlformats.org/drawingml/2006/main" r:embed="R9c28b08b604b4ace"/>
           <a:stretch xmlns:a="http://schemas.openxmlformats.org/drawingml/2006/main"/>
         </p:blipFill>
         <p:spPr>
@@ -2602,7 +2603,7 @@
                 <a:ea typeface="Apple SD Gothic Neo"/>
                 <a:cs typeface="Apple SD Gothic Neo"/>
               </a:rPr>
-              <a:t>• SPY · QQQ · NVDA 등 약 22종목</a:t>
+              <a:t>• 검증 종목: SPY · QQQ · NVDA</a:t>
             </a:r>
           </a:p>
           <a:p xmlns:a="http://schemas.openxmlformats.org/drawingml/2006/main">
@@ -2626,7 +2627,7 @@
                 <a:ea typeface="Apple SD Gothic Neo"/>
                 <a:cs typeface="Apple SD Gothic Neo"/>
               </a:rPr>
-              <a:t>• 거래 가격, 수량, 거래소, 조건, 거래 시각</a:t>
+              <a:t>• 종목, 거래 ID, 거래소, 가격, 수량, 조건, 거래 시각</a:t>
             </a:r>
           </a:p>
           <a:p xmlns:a="http://schemas.openxmlformats.org/drawingml/2006/main">
@@ -2650,7 +2651,7 @@
                 <a:ea typeface="Apple SD Gothic Neo"/>
                 <a:cs typeface="Apple SD Gothic Neo"/>
               </a:rPr>
-              <a:t>• 장 운영 중 들어오는 실제 trade를 Kafka로 전달</a:t>
+              <a:t>• 실제 trade 10건을 Kafka 발행·재소비</a:t>
             </a:r>
           </a:p>
         </p:txBody>
@@ -2797,7 +2798,7 @@
                 <a:ea typeface="Apple SD Gothic Neo"/>
                 <a:cs typeface="Apple SD Gothic Neo"/>
               </a:rPr>
-              <a:t>• WebSocket과 같은 실제 trade field 사용</a:t>
+              <a:t>• 검증 종목: SMH</a:t>
             </a:r>
           </a:p>
           <a:p xmlns:a="http://schemas.openxmlformats.org/drawingml/2006/main">
@@ -2821,7 +2822,7 @@
                 <a:ea typeface="Apple SD Gothic Neo"/>
                 <a:cs typeface="Apple SD Gothic Neo"/>
               </a:rPr>
-              <a:t>• 장 종료 후에도 구간을 정해 다시 실행 가능</a:t>
+              <a:t>• 2026-08-19 19:50Z~19:56Z 실제 IEX 거래</a:t>
             </a:r>
           </a:p>
           <a:p xmlns:a="http://schemas.openxmlformats.org/drawingml/2006/main">
@@ -2947,7 +2948,7 @@
           <p:nvPr/>
         </p:nvPicPr>
         <p:blipFill>
-          <a:blip xmlns:r="http://schemas.openxmlformats.org/officeDocument/2006/relationships" xmlns:a="http://schemas.openxmlformats.org/drawingml/2006/main" r:embed="Rb1e4fe6b44e74c74"/>
+          <a:blip xmlns:r="http://schemas.openxmlformats.org/officeDocument/2006/relationships" xmlns:a="http://schemas.openxmlformats.org/drawingml/2006/main" r:embed="Rc0916642b8f04537"/>
           <a:stretch xmlns:a="http://schemas.openxmlformats.org/drawingml/2006/main"/>
         </p:blipFill>
         <p:spPr>
@@ -3785,7 +3786,7 @@
                 <a:ea typeface="Apple SD Gothic Neo"/>
                 <a:cs typeface="Apple SD Gothic Neo"/>
               </a:rPr>
-              <a:t>Docker Compose는 Kafka와 PostgreSQL의 실행 환경을 같은 명령으로 재현합니다.</a:t>
+              <a:t>Spark는 부하 테스트로 사용 근거를 검증하고, Airflow는 경제지표·과거 데이터 배치에 사용할 예정입니다.</a:t>
             </a:r>
           </a:p>
         </p:txBody>
@@ -4441,7 +4442,7 @@
                 <a:ea typeface="Apple SD Gothic Neo"/>
                 <a:cs typeface="Apple SD Gothic Neo"/>
               </a:rPr>
-              <a:t>3</a:t>
+              <a:t>174</a:t>
             </a:r>
           </a:p>
         </p:txBody>
@@ -4500,7 +4501,7 @@
                 <a:ea typeface="Apple SD Gothic Neo"/>
                 <a:cs typeface="Apple SD Gothic Neo"/>
               </a:rPr>
-              <a:t>최종 1분봉</a:t>
+              <a:t>확정 봉 반영 거래</a:t>
             </a:r>
           </a:p>
         </p:txBody>
@@ -4559,7 +4560,7 @@
                 <a:ea typeface="Apple SD Gothic Neo"/>
                 <a:cs typeface="Apple SD Gothic Neo"/>
               </a:rPr>
-              <a:t>19:50Z~19:52Z · watermark 확정</a:t>
+              <a:t>3개 final 1분봉 · watermark 확정</a:t>
             </a:r>
           </a:p>
         </p:txBody>
@@ -5108,7 +5109,7 @@
           <p:nvPr/>
         </p:nvPicPr>
         <p:blipFill>
-          <a:blip xmlns:r="http://schemas.openxmlformats.org/officeDocument/2006/relationships" xmlns:a="http://schemas.openxmlformats.org/drawingml/2006/main" r:embed="R93661cf571624f23"/>
+          <a:blip xmlns:r="http://schemas.openxmlformats.org/officeDocument/2006/relationships" xmlns:a="http://schemas.openxmlformats.org/drawingml/2006/main" r:embed="Ra635db45f9e641b3"/>
           <a:stretch xmlns:a="http://schemas.openxmlformats.org/drawingml/2006/main"/>
         </p:blipFill>
         <p:spPr>
@@ -5130,7 +5131,7 @@
           <p:nvPr/>
         </p:nvPicPr>
         <p:blipFill>
-          <a:blip xmlns:r="http://schemas.openxmlformats.org/officeDocument/2006/relationships" xmlns:a="http://schemas.openxmlformats.org/drawingml/2006/main" r:embed="R0bce8c6a7ccf423a"/>
+          <a:blip xmlns:r="http://schemas.openxmlformats.org/officeDocument/2006/relationships" xmlns:a="http://schemas.openxmlformats.org/drawingml/2006/main" r:embed="Rca651b0febe94822"/>
           <a:stretch xmlns:a="http://schemas.openxmlformats.org/drawingml/2006/main"/>
         </p:blipFill>
         <p:spPr>
@@ -5315,7 +5316,7 @@
                 <a:ea typeface="Apple SD Gothic Neo"/>
                 <a:cs typeface="Apple SD Gothic Neo"/>
               </a:rPr>
-              <a:t>캡처에는 API key, connection URL, 원본 payload를 포함하지 않았습니다.</a:t>
+              <a:t>GitHub에는 API key, connection URL, 실제 원본 payload를 포함하지 않았습니다.</a:t>
             </a:r>
           </a:p>
         </p:txBody>
@@ -5746,7 +5747,7 @@
                 <a:ea typeface="Apple SD Gothic Neo"/>
                 <a:cs typeface="Apple SD Gothic Neo"/>
               </a:rPr>
-              <a:t>다음 미국 정규장 WebSocket → PostgreSQL E2E</a:t>
+              <a:t>다음 정규장 WebSocket → PostgreSQL E2E</a:t>
             </a:r>
           </a:p>
           <a:p xmlns:a="http://schemas.openxmlformats.org/drawingml/2006/main">
@@ -5770,7 +5771,7 @@
                 <a:ea typeface="Apple SD Gothic Neo"/>
                 <a:cs typeface="Apple SD Gothic Neo"/>
               </a:rPr>
-              <a:t>FRED/ALFRED 경제지표와 발표 전후 영향 분석</a:t>
+              <a:t>Airflow로 공식 경제지표 수집 → 발표 전후 영향 분석</a:t>
             </a:r>
           </a:p>
         </p:txBody>
@@ -5860,7 +5861,7 @@
                 <a:ea typeface="Apple SD Gothic Neo"/>
                 <a:cs typeface="Apple SD Gothic Neo"/>
               </a:rPr>
-              <a:t>피드백 요청: 현재 IEX 범위와 Spark 사용 근거가 적절한가?</a:t>
+              <a:t>피드백 요청: 현재 규모의 Spark 사용 근거와 Kafka 24시간 보관 정책이 적절한가?</a:t>
             </a:r>
           </a:p>
         </p:txBody>

</xml_diff>

<commit_message>
docs: refine kafka spark assignment evidence
</commit_message>
<xml_diff>
--- a/docs/presentation/us-market-pipeline-assignment.pptx
+++ b/docs/presentation/us-market-pipeline-assignment.pptx
@@ -2,19 +2,19 @@
 <file path=ppt/presentation.xml><?xml version="1.0" encoding="utf-8"?>
 <p:presentation xmlns:p="http://schemas.openxmlformats.org/presentationml/2006/main">
   <p:sldMasterIdLst>
-    <p:sldMasterId xmlns:r="http://schemas.openxmlformats.org/officeDocument/2006/relationships" id="2147483648" r:id="R8b1db6b6e43545ae"/>
+    <p:sldMasterId xmlns:r="http://schemas.openxmlformats.org/officeDocument/2006/relationships" id="2147483648" r:id="R1b789427a9bc4009"/>
   </p:sldMasterIdLst>
   <p:notesMasterIdLst>
-    <p:notesMasterId xmlns:r="http://schemas.openxmlformats.org/officeDocument/2006/relationships" r:id="R5f6122255568499c"/>
+    <p:notesMasterId xmlns:r="http://schemas.openxmlformats.org/officeDocument/2006/relationships" r:id="Ra12cab53a6904787"/>
   </p:notesMasterIdLst>
   <p:sldIdLst>
-    <p:sldId xmlns:r="http://schemas.openxmlformats.org/officeDocument/2006/relationships" id="256" r:id="Rc8fc4f1df33049e0"/>
-    <p:sldId xmlns:r="http://schemas.openxmlformats.org/officeDocument/2006/relationships" id="257" r:id="R9ea472c6c39342dc"/>
-    <p:sldId xmlns:r="http://schemas.openxmlformats.org/officeDocument/2006/relationships" id="258" r:id="Rc16c077b62764a3b"/>
-    <p:sldId xmlns:r="http://schemas.openxmlformats.org/officeDocument/2006/relationships" id="259" r:id="Rc5687a7a8f8642e7"/>
-    <p:sldId xmlns:r="http://schemas.openxmlformats.org/officeDocument/2006/relationships" id="260" r:id="Re667162faf924031"/>
-    <p:sldId xmlns:r="http://schemas.openxmlformats.org/officeDocument/2006/relationships" id="261" r:id="R1571352f88b346f5"/>
-    <p:sldId xmlns:r="http://schemas.openxmlformats.org/officeDocument/2006/relationships" id="262" r:id="R19de9f576f434b0b"/>
+    <p:sldId xmlns:r="http://schemas.openxmlformats.org/officeDocument/2006/relationships" id="256" r:id="Rf3b2b3b9cfdb49bb"/>
+    <p:sldId xmlns:r="http://schemas.openxmlformats.org/officeDocument/2006/relationships" id="257" r:id="R08be589e0c674ae5"/>
+    <p:sldId xmlns:r="http://schemas.openxmlformats.org/officeDocument/2006/relationships" id="258" r:id="R7db1bf9e360a4e90"/>
+    <p:sldId xmlns:r="http://schemas.openxmlformats.org/officeDocument/2006/relationships" id="259" r:id="R560b503c58594986"/>
+    <p:sldId xmlns:r="http://schemas.openxmlformats.org/officeDocument/2006/relationships" id="260" r:id="R679b4b97d4c94f1e"/>
+    <p:sldId xmlns:r="http://schemas.openxmlformats.org/officeDocument/2006/relationships" id="261" r:id="R90806bc28d7f4092"/>
+    <p:sldId xmlns:r="http://schemas.openxmlformats.org/officeDocument/2006/relationships" id="262" r:id="R417fe89fe53648cf"/>
   </p:sldIdLst>
   <p:sldSz cx="12192000" cy="6858000"/>
   <p:notesSz cx="6858000" cy="9144000"/>
@@ -448,7 +448,7 @@
           <a:lstStyle xmlns:a="http://schemas.openxmlformats.org/drawingml/2006/main"/>
           <a:p xmlns:a="http://schemas.openxmlformats.org/drawingml/2006/main">
             <a:r>
-              <a:t>안녕하세요. 제 프로젝트는 실제 미국 주식 거래 데이터를 수집해서 1분봉으로 저장하는 데이터 파이프라인입니다. 최종적으로는 CPI, 고용, 금리 같은 경제지표 발표 전후에 주가와 거래량, 변동성이 어떻게 달라졌는지 검증하려고 합니다. 이번 과제에서는 분석이나 주문 기능보다 실제 데이터가 수집되고 처리되고 저장되는 전체 흐름에 집중했습니다.</a:t>
+              <a:t>안녕하세요. 이번 과제에서는 2026년 8월 12일 CPI 발표 전후 지정 구간에 대해 Alpaca Historical SIP Trades API가 반환한 NVDA 개별 체결 레코드 58,036건을 Kafka와 Spark로 처리해 PostgreSQL에 저장했습니다. 58,036건은 SIP 전체 시장 거래량이 아닙니다. 전체 프로젝트의 목표는 경제지표 발표 전후 시장 반응을 검증하는 것이고, 오늘은 그 데이터 처리 경로의 실제 실행 결과에 집중하겠습니다.</a:t>
             </a:r>
           </a:p>
           <a:p xmlns:a="http://schemas.openxmlformats.org/drawingml/2006/main">
@@ -463,12 +463,12 @@
           </a:p>
           <a:p xmlns:a="http://schemas.openxmlformats.org/drawingml/2006/main">
             <a:r>
-              <a:t>- /Users/hanjeonghyun/dev/2026/for_my_stock/README.md</a:t>
-            </a:r>
-          </a:p>
-          <a:p xmlns:a="http://schemas.openxmlformats.org/drawingml/2006/main">
-            <a:r>
-              <a:t>- /Users/hanjeonghyun/dev/2026/for_my_stock/docs/final-vision.md</a:t>
+              <a:t>- https://github.com/hjh6709/us-market-intelligence-pipeline/blob/main/README.md</a:t>
+            </a:r>
+          </a:p>
+          <a:p xmlns:a="http://schemas.openxmlformats.org/drawingml/2006/main">
+            <a:r>
+              <a:t>- https://github.com/hjh6709/us-market-intelligence-pipeline/blob/main/docs/evidence/cpi-kafka-spark/result.json</a:t>
             </a:r>
           </a:p>
           <a:p xmlns:a="http://schemas.openxmlformats.org/drawingml/2006/main">
@@ -543,7 +543,7 @@
           <a:lstStyle xmlns:a="http://schemas.openxmlformats.org/drawingml/2006/main"/>
           <a:p xmlns:a="http://schemas.openxmlformats.org/drawingml/2006/main">
             <a:r>
-              <a:t>주식 데이터는 Alpaca에서 가져옵니다. WebSocket에서는 SPY, QQQ, NVDA 실제 거래 10건을 Kafka까지 확인했습니다. 같은 처리를 다시 확인하기 위해 Historical API에서 SMH의 2026년 8월 19일 19시 50분부터 19시 56분까지 실제 거래도 가져왔습니다. 다음 단계에서는 BLS, BEA, 연준의 공식 경제지표를 FRED와 ALFRED의 시계열 및 당시 공개 값과 함께 수집할 계획입니다. 경제지표 수집은 아직 구현 전입니다.</a:t>
+              <a:t>실시간 IEX WebSocket 경로와 이번 과제의 Historical SIP replay는 역할이 다릅니다. IEX는 실시간 예비 관측용이고, 이번 과제는 여러 거래소를 통합한 SIP의 과거 NVDA 체결을 사용했습니다.</a:t>
             </a:r>
           </a:p>
           <a:p xmlns:a="http://schemas.openxmlformats.org/drawingml/2006/main">
@@ -558,22 +558,12 @@
           </a:p>
           <a:p xmlns:a="http://schemas.openxmlformats.org/drawingml/2006/main">
             <a:r>
-              <a:t>- https://docs.alpaca.markets/us/docs/real-time-stock-pricing-data</a:t>
-            </a:r>
-          </a:p>
-          <a:p xmlns:a="http://schemas.openxmlformats.org/drawingml/2006/main">
-            <a:r>
-              <a:t>- https://docs.alpaca.markets/us/reference/stocktradesingle-1</a:t>
-            </a:r>
-          </a:p>
-          <a:p xmlns:a="http://schemas.openxmlformats.org/drawingml/2006/main">
-            <a:r>
-              <a:t>- /Users/hanjeonghyun/dev/2026/for_my_stock/docs/data-source-catalog.md</a:t>
-            </a:r>
-          </a:p>
-          <a:p xmlns:a="http://schemas.openxmlformats.org/drawingml/2006/main">
-            <a:r>
-              <a:t>- /Users/hanjeonghyun/dev/2026/for_my_stock/docs/test-results/2026-08-19-kafka-producer-smoke.md</a:t>
+              <a:t>- https://github.com/hjh6709/us-market-intelligence-pipeline/blob/main/docs/data-source-catalog.md</a:t>
+            </a:r>
+          </a:p>
+          <a:p xmlns:a="http://schemas.openxmlformats.org/drawingml/2006/main">
+            <a:r>
+              <a:t>- https://github.com/hjh6709/us-market-intelligence-pipeline/blob/main/docs/test-results/2026-08-24-cpi-kafka-spark.md</a:t>
             </a:r>
           </a:p>
           <a:p xmlns:a="http://schemas.openxmlformats.org/drawingml/2006/main">
@@ -648,7 +638,7 @@
           <a:lstStyle xmlns:a="http://schemas.openxmlformats.org/drawingml/2006/main"/>
           <a:p xmlns:a="http://schemas.openxmlformats.org/drawingml/2006/main">
             <a:r>
-              <a:t>현재 흐름은 Alpaca, Python 수집기, Kafka, Spark, PostgreSQL 순서입니다. Kafka는 원본 거래를 24시간 보관하고, Spark는 개별 거래를 1분 단위로 묶어 OHLCV와 거래 건수, VWAP을 계산합니다. 완성된 1분봉은 PostgreSQL에 저장합니다. 그림 아래쪽의 경제지표 수집과 Airflow 배치, 분석 화면은 앞으로 구현할 부분입니다.</a:t>
+              <a:t>CPI 발표 시각 12시 30분 UTC를 기준으로 11시 30분 이상 13시 31분 미만의 원시 체결을 가져왔습니다. Producer, Consumer와 Spark 입력이 모두 58,036건으로 일치하고 Spark는 121개 1분봉을 저장했습니다.</a:t>
             </a:r>
           </a:p>
           <a:p xmlns:a="http://schemas.openxmlformats.org/drawingml/2006/main">
@@ -663,12 +653,12 @@
           </a:p>
           <a:p xmlns:a="http://schemas.openxmlformats.org/drawingml/2006/main">
             <a:r>
-              <a:t>- /Users/hanjeonghyun/dev/2026/for_my_stock/docs/diagrams/pipeline-architecture.png</a:t>
-            </a:r>
-          </a:p>
-          <a:p xmlns:a="http://schemas.openxmlformats.org/drawingml/2006/main">
-            <a:r>
-              <a:t>- /Users/hanjeonghyun/dev/2026/for_my_stock/docs/architecture.md</a:t>
+              <a:t>- https://github.com/hjh6709/us-market-intelligence-pipeline/blob/main/docs/diagrams/cpi-sip-kafka-spark-assignment.png</a:t>
+            </a:r>
+          </a:p>
+          <a:p xmlns:a="http://schemas.openxmlformats.org/drawingml/2006/main">
+            <a:r>
+              <a:t>- https://github.com/hjh6709/us-market-intelligence-pipeline/blob/main/docs/evidence/cpi-kafka-spark/result.json</a:t>
             </a:r>
           </a:p>
           <a:p xmlns:a="http://schemas.openxmlformats.org/drawingml/2006/main">
@@ -743,7 +733,7 @@
           <a:lstStyle xmlns:a="http://schemas.openxmlformats.org/drawingml/2006/main"/>
           <a:p xmlns:a="http://schemas.openxmlformats.org/drawingml/2006/main">
             <a:r>
-              <a:t>Kafka는 수집과 처리를 분리하고 장애가 생겨도 원본 데이터를 다시 읽기 위해 사용했습니다. Spark는 실제 거래 시각 기준의 1분 집계와 중복·지연 데이터 처리를 맡습니다. 현재 규모에는 큰 기술일 수 있어 이후 부하 테스트로 사용 근거를 확인할 계획입니다. PostgreSQL은 최종 결과를 SQL로 조회하고 중복 없이 저장하기 위해 선택했습니다. Airflow는 경제지표와 과거 데이터 배치에 사용할 예정입니다.</a:t>
+              <a:t>Kafka는 수집과 처리를 분리하고 원시 이벤트를 24시간 보관합니다. Spark batch는 Kafka의 같은 JSON을 읽어 검증, 중복 제거와 event-time 1분 집계를 수행합니다. PostgreSQL은 source와 feed를 포함한 business key로 결과를 멱등 저장합니다.</a:t>
             </a:r>
           </a:p>
           <a:p xmlns:a="http://schemas.openxmlformats.org/drawingml/2006/main">
@@ -758,12 +748,12 @@
           </a:p>
           <a:p xmlns:a="http://schemas.openxmlformats.org/drawingml/2006/main">
             <a:r>
-              <a:t>- /Users/hanjeonghyun/dev/2026/for_my_stock/docs/design-decisions.md</a:t>
-            </a:r>
-          </a:p>
-          <a:p xmlns:a="http://schemas.openxmlformats.org/drawingml/2006/main">
-            <a:r>
-              <a:t>- /Users/hanjeonghyun/dev/2026/for_my_stock/docs/architecture.md</a:t>
+              <a:t>- https://github.com/hjh6709/us-market-intelligence-pipeline/blob/main/docs/kafka-spark-assignment.md</a:t>
+            </a:r>
+          </a:p>
+          <a:p xmlns:a="http://schemas.openxmlformats.org/drawingml/2006/main">
+            <a:r>
+              <a:t>- https://github.com/hjh6709/us-market-intelligence-pipeline/blob/main/src/spark_sip_trade_batch.py</a:t>
             </a:r>
           </a:p>
           <a:p xmlns:a="http://schemas.openxmlformats.org/drawingml/2006/main">
@@ -838,7 +828,7 @@
           <a:lstStyle xmlns:a="http://schemas.openxmlformats.org/drawingml/2006/main"/>
           <a:p xmlns:a="http://schemas.openxmlformats.org/drawingml/2006/main">
             <a:r>
-              <a:t>Historical API에서 SMH 실제 거래 427건을 가져와 Kafka에 모두 발행했습니다. 실행 종료 전에 watermark를 통과한 거래 174건이 PostgreSQL의 확정 1분봉 3건에 반영됐고 중복 키는 0건이었습니다. 나머지 거래는 종료 시점에 아직 watermark를 통과하지 않아 final row로 저장되지 않았습니다. WebSocket 실제 거래 10건은 Kafka까지 확인했고 PostgreSQL까지의 실시간 전체 경로는 아직 검증 전입니다.</a:t>
+              <a:t>NVDA와 지정 시간 조건으로 Historical SIP Trades API가 반환한 체결 레코드 58,036건을 Kafka에 발행했고 Consumer에서도 58,036건을 확인했습니다. Spark 입력, 유효, 고유 레코드도 모두 58,036건이며 오류와 중복은 0건입니다. 최종 결과는 121개 1분봉입니다.</a:t>
             </a:r>
           </a:p>
           <a:p xmlns:a="http://schemas.openxmlformats.org/drawingml/2006/main">
@@ -853,12 +843,12 @@
           </a:p>
           <a:p xmlns:a="http://schemas.openxmlformats.org/drawingml/2006/main">
             <a:r>
-              <a:t>- /Users/hanjeonghyun/dev/2026/for_my_stock/docs/evidence/actual-ingestion/result.json</a:t>
-            </a:r>
-          </a:p>
-          <a:p xmlns:a="http://schemas.openxmlformats.org/drawingml/2006/main">
-            <a:r>
-              <a:t>- /Users/hanjeonghyun/dev/2026/for_my_stock/docs/test-results/2026-08-20-actual-ingestion.md</a:t>
+              <a:t>- https://github.com/hjh6709/us-market-intelligence-pipeline/blob/main/docs/evidence/cpi-kafka-spark/result.json</a:t>
+            </a:r>
+          </a:p>
+          <a:p xmlns:a="http://schemas.openxmlformats.org/drawingml/2006/main">
+            <a:r>
+              <a:t>- https://github.com/hjh6709/us-market-intelligence-pipeline/blob/main/docs/test-results/2026-08-24-cpi-kafka-spark.md</a:t>
             </a:r>
           </a:p>
           <a:p xmlns:a="http://schemas.openxmlformats.org/drawingml/2006/main">
@@ -933,7 +923,7 @@
           <a:lstStyle xmlns:a="http://schemas.openxmlformats.org/drawingml/2006/main"/>
           <a:p xmlns:a="http://schemas.openxmlformats.org/drawingml/2006/main">
             <a:r>
-              <a:t>자동 테스트 45개와 Kafka·Spark 통합 테스트 2개를 통과했습니다. 늦게 도착한 데이터와 중복 데이터 처리, Spark 재시작, PostgreSQL 장애 후 재처리도 확인했습니다. API 키와 실제 원본 데이터는 GitHub에 올리지 않았습니다.</a:t>
+              <a:t>왼쪽은 공개 result.json에 남긴 실제 처리 건수이고 오른쪽은 로컬 PostgreSQL 증거 SQL의 실제 실행 결과입니다. API key와 원시 payload는 공개하지 않지만, 코드와 집계 결과, 실제 DB 조회는 재현할 수 있습니다.</a:t>
             </a:r>
           </a:p>
           <a:p xmlns:a="http://schemas.openxmlformats.org/drawingml/2006/main">
@@ -948,17 +938,12 @@
           </a:p>
           <a:p xmlns:a="http://schemas.openxmlformats.org/drawingml/2006/main">
             <a:r>
-              <a:t>- /Users/hanjeonghyun/dev/2026/for_my_stock/docs/evidence/presentation-captures/05_automated_tests.png</a:t>
-            </a:r>
-          </a:p>
-          <a:p xmlns:a="http://schemas.openxmlformats.org/drawingml/2006/main">
-            <a:r>
-              <a:t>- /Users/hanjeonghyun/dev/2026/for_my_stock/docs/evidence/presentation-captures/06_database_recovery.png</a:t>
-            </a:r>
-          </a:p>
-          <a:p xmlns:a="http://schemas.openxmlformats.org/drawingml/2006/main">
-            <a:r>
-              <a:t>- /Users/hanjeonghyun/dev/2026/for_my_stock/docs/evidence/postgres-market-bars/result.json</a:t>
+              <a:t>- https://github.com/hjh6709/us-market-intelligence-pipeline/blob/main/docs/evidence/cpi-kafka-spark/result.json</a:t>
+            </a:r>
+          </a:p>
+          <a:p xmlns:a="http://schemas.openxmlformats.org/drawingml/2006/main">
+            <a:r>
+              <a:t>- https://github.com/hjh6709/us-market-intelligence-pipeline/blob/main/scripts/evidence/cpi_sip_kafka_spark_evidence.sql</a:t>
             </a:r>
           </a:p>
           <a:p xmlns:a="http://schemas.openxmlformats.org/drawingml/2006/main">
@@ -1033,7 +1018,7 @@
           <a:lstStyle xmlns:a="http://schemas.openxmlformats.org/drawingml/2006/main"/>
           <a:p xmlns:a="http://schemas.openxmlformats.org/drawingml/2006/main">
             <a:r>
-              <a:t>이번 과제에서는 전체 아키텍처를 그리고 실제 데이터를 수집해 PostgreSQL에 저장하는 단계까지 완료했습니다. 다음에는 정규장에 WebSocket부터 PostgreSQL까지 전체 경로를 검증하겠습니다. 이후 공식 경제지표를 추가해 발표 전후 5분, 30분, 60분 동안 가격과 거래량, 변동성이 어떻게 달라졌는지 비교할 계획입니다. 멘토님께는 현재 검증 규모의 Spark 사용 근거와 Kafka의 24시간 보관 정책이 적절한지 피드백을 받고 싶습니다.</a:t>
+              <a:t>이번 과제의 필수 범위인 메시지 명세, 100건 이상 전송, Producer와 Consumer 대조, Spark 전처리와 DB 저장을 완료했습니다. 다음에는 여러 CPI 발표일과 종목으로 분석 범위를 정제하고 Airflow로 반복 수집과 품질 검사를 자동화하겠습니다.</a:t>
             </a:r>
           </a:p>
           <a:p xmlns:a="http://schemas.openxmlformats.org/drawingml/2006/main">
@@ -1048,12 +1033,12 @@
           </a:p>
           <a:p xmlns:a="http://schemas.openxmlformats.org/drawingml/2006/main">
             <a:r>
-              <a:t>- /Users/hanjeonghyun/dev/2026/for_my_stock/README.md</a:t>
-            </a:r>
-          </a:p>
-          <a:p xmlns:a="http://schemas.openxmlformats.org/drawingml/2006/main">
-            <a:r>
-              <a:t>- /Users/hanjeonghyun/dev/2026/for_my_stock/docs/final-vision.md</a:t>
+              <a:t>- https://github.com/hjh6709/us-market-intelligence-pipeline/blob/main/docs/submission-checklist.md</a:t>
+            </a:r>
+          </a:p>
+          <a:p xmlns:a="http://schemas.openxmlformats.org/drawingml/2006/main">
+            <a:r>
+              <a:t>- https://github.com/hjh6709/us-market-intelligence-pipeline/blob/main/PROJECT_PLAN.md</a:t>
             </a:r>
           </a:p>
           <a:p xmlns:a="http://schemas.openxmlformats.org/drawingml/2006/main">
@@ -1126,7 +1111,7 @@
   </p:cSld>
   <p:clrMap bg1="lt1" tx1="dk1" bg2="lt2" tx2="dk2" accent1="accent1" accent2="accent2" accent3="accent3" accent4="accent4" accent5="accent5" accent6="accent6" hlink="hlink" folHlink="folHlink"/>
   <p:sldLayoutIdLst>
-    <p:sldLayoutId xmlns:r="http://schemas.openxmlformats.org/officeDocument/2006/relationships" id="2147483649" r:id="R2dd27509997c47c7"/>
+    <p:sldLayoutId xmlns:r="http://schemas.openxmlformats.org/officeDocument/2006/relationships" id="2147483649" r:id="Rb8795eb59809404b"/>
   </p:sldLayoutIdLst>
   <p:txStyles>
     <p:titleStyle>
@@ -1726,7 +1711,7 @@
                 <a:ea typeface="Apple SD Gothic Neo"/>
                 <a:cs typeface="Apple SD Gothic Neo"/>
               </a:rPr>
-              <a:t>2차시 과제 · 데이터 구조 설계</a:t>
+              <a:t>4차시 과제 · Kafka·Spark 전처리·저장</a:t>
             </a:r>
           </a:p>
         </p:txBody>
@@ -1785,7 +1770,7 @@
                 <a:ea typeface="Apple SD Gothic Neo"/>
                 <a:cs typeface="Apple SD Gothic Neo"/>
               </a:rPr>
-              <a:t>실제 미국 주식 거래를</a:t>
+              <a:t>NVDA SIP 체결 레코드</a:t>
             </a:r>
           </a:p>
           <a:p xmlns:a="http://schemas.openxmlformats.org/drawingml/2006/main">
@@ -1809,7 +1794,7 @@
                 <a:ea typeface="Apple SD Gothic Neo"/>
                 <a:cs typeface="Apple SD Gothic Neo"/>
               </a:rPr>
-              <a:t>1분봉으로 저장했습니다</a:t>
+              <a:t>58,036건을 처리했습니다</a:t>
             </a:r>
           </a:p>
         </p:txBody>
@@ -1927,8 +1912,31 @@
                 <a:ea typeface="Apple SD Gothic Neo"/>
                 <a:cs typeface="Apple SD Gothic Neo"/>
               </a:rPr>
-              <a:t>최종 목표: 경제지표 발표 전후 시장 반응 검증
-이번 범위: 실제 데이터 → Ingestion → Data Storage</a:t>
+              <a:t>최종 목표: 경제지표 발표 전후 시장 반응 검증</a:t>
+            </a:r>
+          </a:p>
+          <a:p xmlns:a="http://schemas.openxmlformats.org/drawingml/2006/main">
+            <a:pPr algn="l">
+              <a:buNone/>
+              <a:defRPr sz="1575" b="0">
+                <a:solidFill>
+                  <a:srgbClr val="667085"/>
+                </a:solidFill>
+                <a:latin typeface="Apple SD Gothic Neo"/>
+                <a:ea typeface="Apple SD Gothic Neo"/>
+                <a:cs typeface="Apple SD Gothic Neo"/>
+              </a:defRPr>
+            </a:pPr>
+            <a:r>
+              <a:rPr sz="1575" b="0">
+                <a:solidFill>
+                  <a:srgbClr val="667085"/>
+                </a:solidFill>
+                <a:latin typeface="Apple SD Gothic Neo"/>
+                <a:ea typeface="Apple SD Gothic Neo"/>
+                <a:cs typeface="Apple SD Gothic Neo"/>
+              </a:rPr>
+              <a:t>이번 범위: SIP raw trade → Kafka → Spark → PostgreSQL</a:t>
             </a:r>
           </a:p>
         </p:txBody>
@@ -1987,7 +1995,7 @@
                 <a:ea typeface="Apple SD Gothic Neo"/>
                 <a:cs typeface="Apple SD Gothic Neo"/>
               </a:rPr>
-              <a:t>Alpaca · Kafka · Spark Structured Streaming · PostgreSQL</a:t>
+              <a:t>Alpaca SIP · Kafka · Spark Batch · PostgreSQL</a:t>
             </a:r>
           </a:p>
         </p:txBody>
@@ -2034,11 +2042,11 @@
           <p:nvPr/>
         </p:nvPicPr>
         <p:blipFill>
-          <a:blip xmlns:r="http://schemas.openxmlformats.org/officeDocument/2006/relationships" xmlns:a="http://schemas.openxmlformats.org/drawingml/2006/main" r:embed="R9c28b08b604b4ace"/>
+          <a:blip xmlns:r="http://schemas.openxmlformats.org/officeDocument/2006/relationships" xmlns:a="http://schemas.openxmlformats.org/drawingml/2006/main" r:embed="R3eeb8ee9bd5a4067"/>
           <a:stretch xmlns:a="http://schemas.openxmlformats.org/drawingml/2006/main"/>
         </p:blipFill>
         <p:spPr>
-          <a:xfrm xmlns:a="http://schemas.openxmlformats.org/drawingml/2006/main">
+          <a:xfrm xmlns:a="http://schemas.openxmlformats.org/drawingml/2006/main" flipH="0" flipV="0">
             <a:off x="6076950" y="1296591"/>
             <a:ext cx="5448300" cy="3064669"/>
           </a:xfrm>
@@ -2160,7 +2168,7 @@
                 <a:ea typeface="Apple SD Gothic Neo"/>
                 <a:cs typeface="Apple SD Gothic Neo"/>
               </a:rPr>
-              <a:t>Kafka raw storage와 PostgreSQL processed storage가 모두 healthy이며, 원본 토픽 오프셋도 확인했습니다.</a:t>
+              <a:t>Producer·Consumer·Spark 58,036건 일치 · PostgreSQL 1분봉 121건 저장</a:t>
             </a:r>
           </a:p>
         </p:txBody>
@@ -2366,7 +2374,7 @@
                 <a:ea typeface="Apple SD Gothic Neo"/>
                 <a:cs typeface="Apple SD Gothic Neo"/>
               </a:rPr>
-              <a:t>같은 실제 거래를 실시간과 재현 가능한 방식으로 수집합니다</a:t>
+              <a:t>실시간 IEX와 과제용 SIP replay의 역할을 분리했습니다</a:t>
             </a:r>
           </a:p>
         </p:txBody>
@@ -2627,7 +2635,7 @@
                 <a:ea typeface="Apple SD Gothic Neo"/>
                 <a:cs typeface="Apple SD Gothic Neo"/>
               </a:rPr>
-              <a:t>• 종목, 거래 ID, 거래소, 가격, 수량, 조건, 거래 시각</a:t>
+              <a:t>• 실제 거래 시각·가격·수량·조건 수집</a:t>
             </a:r>
           </a:p>
           <a:p xmlns:a="http://schemas.openxmlformats.org/drawingml/2006/main">
@@ -2769,7 +2777,7 @@
                 <a:ea typeface="Apple SD Gothic Neo"/>
                 <a:cs typeface="Apple SD Gothic Neo"/>
               </a:rPr>
-              <a:t>Alpaca Historical Trades REST</a:t>
+              <a:t>Alpaca Historical SIP Trades</a:t>
             </a:r>
           </a:p>
           <a:p xmlns:a="http://schemas.openxmlformats.org/drawingml/2006/main">
@@ -2798,7 +2806,7 @@
                 <a:ea typeface="Apple SD Gothic Neo"/>
                 <a:cs typeface="Apple SD Gothic Neo"/>
               </a:rPr>
-              <a:t>• 검증 종목: SMH</a:t>
+              <a:t>• NVDA · 11:30~13:31 UTC</a:t>
             </a:r>
           </a:p>
           <a:p xmlns:a="http://schemas.openxmlformats.org/drawingml/2006/main">
@@ -2822,7 +2830,7 @@
                 <a:ea typeface="Apple SD Gothic Neo"/>
                 <a:cs typeface="Apple SD Gothic Neo"/>
               </a:rPr>
-              <a:t>• 2026-08-19 19:50Z~19:56Z 실제 IEX 거래</a:t>
+              <a:t>• API 체결 레코드 58,036건</a:t>
             </a:r>
           </a:p>
           <a:p xmlns:a="http://schemas.openxmlformats.org/drawingml/2006/main">
@@ -2846,7 +2854,7 @@
                 <a:ea typeface="Apple SD Gothic Neo"/>
                 <a:cs typeface="Apple SD Gothic Neo"/>
               </a:rPr>
-              <a:t>• 고정 fixture는 중복·지연·오류 자동 테스트에만 사용</a:t>
+              <a:t>• Kafka·Spark batch 재현 후 DB 저장</a:t>
             </a:r>
           </a:p>
         </p:txBody>
@@ -2905,7 +2913,7 @@
                 <a:ea typeface="Apple SD Gothic Neo"/>
                 <a:cs typeface="Apple SD Gothic Neo"/>
               </a:rPr>
-              <a:t>무료 IEX는 미국 전체 거래소가 아니므로 결과를 전체 시장으로 확대 해석하지 않습니다.</a:t>
+              <a:t>IEX는 실시간 예비 관측, SIP raw replay는 이번 과제의 통합 시장 과거 검증에 사용합니다.</a:t>
             </a:r>
           </a:p>
         </p:txBody>
@@ -2948,7 +2956,7 @@
           <p:nvPr/>
         </p:nvPicPr>
         <p:blipFill>
-          <a:blip xmlns:r="http://schemas.openxmlformats.org/officeDocument/2006/relationships" xmlns:a="http://schemas.openxmlformats.org/drawingml/2006/main" r:embed="Rc0916642b8f04537"/>
+          <a:blip xmlns:r="http://schemas.openxmlformats.org/officeDocument/2006/relationships" xmlns:a="http://schemas.openxmlformats.org/drawingml/2006/main" r:embed="R73d60b7221b24506"/>
           <a:stretch xmlns:a="http://schemas.openxmlformats.org/drawingml/2006/main"/>
         </p:blipFill>
         <p:spPr>
@@ -3520,7 +3528,7 @@
                 <a:ea typeface="Apple SD Gothic Neo"/>
                 <a:cs typeface="Apple SD Gothic Neo"/>
               </a:rPr>
-              <a:t>거래 도착 순서가 아니라 실제 거래 시각으로 1분봉을 만듭니다.</a:t>
+              <a:t>Kafka JSON을 batch로 읽습니다.</a:t>
             </a:r>
           </a:p>
           <a:p xmlns:a="http://schemas.openxmlformats.org/drawingml/2006/main">
@@ -3549,7 +3557,31 @@
                 <a:ea typeface="Apple SD Gothic Neo"/>
                 <a:cs typeface="Apple SD Gothic Neo"/>
               </a:rPr>
-              <a:t>중복 제거, watermark, checkpoint를 함께 검증합니다.</a:t>
+              <a:t>Schema 검증·중복 제거 후</a:t>
+            </a:r>
+          </a:p>
+          <a:p xmlns:a="http://schemas.openxmlformats.org/drawingml/2006/main">
+            <a:pPr algn="l">
+              <a:buNone/>
+              <a:defRPr sz="1575" b="0">
+                <a:solidFill>
+                  <a:srgbClr val="101828"/>
+                </a:solidFill>
+                <a:latin typeface="Apple SD Gothic Neo"/>
+                <a:ea typeface="Apple SD Gothic Neo"/>
+                <a:cs typeface="Apple SD Gothic Neo"/>
+              </a:defRPr>
+            </a:pPr>
+            <a:r>
+              <a:rPr sz="1575" b="0">
+                <a:solidFill>
+                  <a:srgbClr val="101828"/>
+                </a:solidFill>
+                <a:latin typeface="Apple SD Gothic Neo"/>
+                <a:ea typeface="Apple SD Gothic Neo"/>
+                <a:cs typeface="Apple SD Gothic Neo"/>
+              </a:rPr>
+              <a:t>거래 시각 기준 1분봉을 계산합니다.</a:t>
             </a:r>
           </a:p>
         </p:txBody>
@@ -3786,7 +3818,7 @@
                 <a:ea typeface="Apple SD Gothic Neo"/>
                 <a:cs typeface="Apple SD Gothic Neo"/>
               </a:rPr>
-              <a:t>Spark는 부하 테스트로 사용 근거를 검증하고, Airflow는 경제지표·과거 데이터 배치에 사용할 예정입니다.</a:t>
+              <a:t>Spark는 58,036건의 schema·중복·window 처리를 검증했고, Airflow는 반복 수집·백필 단계에서 도입합니다.</a:t>
             </a:r>
           </a:p>
         </p:txBody>
@@ -3933,7 +3965,7 @@
                 <a:ea typeface="Apple SD Gothic Neo"/>
                 <a:cs typeface="Apple SD Gothic Neo"/>
               </a:rPr>
-              <a:t>실제 거래 427건 발행 후, 174건이 확정 봉 3건에 반영됐습니다</a:t>
+              <a:t>NVDA 체결 58,036건 → 1분봉 121건</a:t>
             </a:r>
           </a:p>
         </p:txBody>
@@ -4082,7 +4114,7 @@
                 <a:ea typeface="Apple SD Gothic Neo"/>
                 <a:cs typeface="Apple SD Gothic Neo"/>
               </a:rPr>
-              <a:t>SMH · 2026-08-19 19:50Z~19:56Z · Alpaca Historical IEX</a:t>
+              <a:t>NVDA · 2026-08-12 11:30Z~13:31Z · Alpaca Historical SIP</a:t>
             </a:r>
           </a:p>
         </p:txBody>
@@ -4203,7 +4235,7 @@
                 <a:ea typeface="Apple SD Gothic Neo"/>
                 <a:cs typeface="Apple SD Gothic Neo"/>
               </a:rPr>
-              <a:t>427</a:t>
+              <a:t>58,036</a:t>
             </a:r>
           </a:p>
         </p:txBody>
@@ -4262,7 +4294,7 @@
                 <a:ea typeface="Apple SD Gothic Neo"/>
                 <a:cs typeface="Apple SD Gothic Neo"/>
               </a:rPr>
-              <a:t>조회 = Kafka 발행</a:t>
+              <a:t>Producer = Consumer</a:t>
             </a:r>
           </a:p>
         </p:txBody>
@@ -4321,7 +4353,7 @@
                 <a:ea typeface="Apple SD Gothic Neo"/>
                 <a:cs typeface="Apple SD Gothic Neo"/>
               </a:rPr>
-              <a:t>실제 trade · API 1 page</a:t>
+              <a:t>NVDA · 지정 구간 · API 6 pages</a:t>
             </a:r>
           </a:p>
         </p:txBody>
@@ -4442,7 +4474,7 @@
                 <a:ea typeface="Apple SD Gothic Neo"/>
                 <a:cs typeface="Apple SD Gothic Neo"/>
               </a:rPr>
-              <a:t>174</a:t>
+              <a:t>58,036</a:t>
             </a:r>
           </a:p>
         </p:txBody>
@@ -4501,7 +4533,7 @@
                 <a:ea typeface="Apple SD Gothic Neo"/>
                 <a:cs typeface="Apple SD Gothic Neo"/>
               </a:rPr>
-              <a:t>확정 봉 반영 거래</a:t>
+              <a:t>Spark 유효·고유 레코드</a:t>
             </a:r>
           </a:p>
         </p:txBody>
@@ -4560,7 +4592,7 @@
                 <a:ea typeface="Apple SD Gothic Neo"/>
                 <a:cs typeface="Apple SD Gothic Neo"/>
               </a:rPr>
-              <a:t>3개 final 1분봉 · watermark 확정</a:t>
+              <a:t>invalid 0 · duplicate 0</a:t>
             </a:r>
           </a:p>
         </p:txBody>
@@ -4681,7 +4713,7 @@
                 <a:ea typeface="Apple SD Gothic Neo"/>
                 <a:cs typeface="Apple SD Gothic Neo"/>
               </a:rPr>
-              <a:t>0</a:t>
+              <a:t>121</a:t>
             </a:r>
           </a:p>
         </p:txBody>
@@ -4740,7 +4772,7 @@
                 <a:ea typeface="Apple SD Gothic Neo"/>
                 <a:cs typeface="Apple SD Gothic Neo"/>
               </a:rPr>
-              <a:t>중복 business key</a:t>
+              <a:t>PostgreSQL 1분봉</a:t>
             </a:r>
           </a:p>
         </p:txBody>
@@ -4799,7 +4831,7 @@
                 <a:ea typeface="Apple SD Gothic Neo"/>
                 <a:cs typeface="Apple SD Gothic Neo"/>
               </a:rPr>
-              <a:t>row 수와 business key 수 일치</a:t>
+              <a:t>11:30–13:30 UTC · key 중복 0</a:t>
             </a:r>
           </a:p>
         </p:txBody>
@@ -4858,7 +4890,7 @@
                 <a:ea typeface="Apple SD Gothic Neo"/>
                 <a:cs typeface="Apple SD Gothic Neo"/>
               </a:rPr>
-              <a:t>나머지 구간은 실행 종료 시 watermark를 통과하지 않아 final row로 저장되지 않았습니다.</a:t>
+              <a:t>provider bar trade_count 58,034건과 raw replay 58,036건은 별도 source로 보존했습니다.</a:t>
             </a:r>
           </a:p>
         </p:txBody>
@@ -5005,7 +5037,7 @@
                 <a:ea typeface="Apple SD Gothic Neo"/>
                 <a:cs typeface="Apple SD Gothic Neo"/>
               </a:rPr>
-              <a:t>정상 실행뿐 아니라 지연·중복·재시작과 DB 장애도 확인했습니다</a:t>
+              <a:t>코드·처리 건수·DB 결과를 서로 대조할 수 있습니다</a:t>
             </a:r>
           </a:p>
         </p:txBody>
@@ -5109,11 +5141,11 @@
           <p:nvPr/>
         </p:nvPicPr>
         <p:blipFill>
-          <a:blip xmlns:r="http://schemas.openxmlformats.org/officeDocument/2006/relationships" xmlns:a="http://schemas.openxmlformats.org/drawingml/2006/main" r:embed="Ra635db45f9e641b3"/>
+          <a:blip xmlns:r="http://schemas.openxmlformats.org/officeDocument/2006/relationships" xmlns:a="http://schemas.openxmlformats.org/drawingml/2006/main" r:embed="R0b6fa035c6034309"/>
           <a:stretch xmlns:a="http://schemas.openxmlformats.org/drawingml/2006/main"/>
         </p:blipFill>
         <p:spPr>
-          <a:xfrm xmlns:a="http://schemas.openxmlformats.org/drawingml/2006/main">
+          <a:xfrm xmlns:a="http://schemas.openxmlformats.org/drawingml/2006/main" flipH="0" flipV="0">
             <a:off x="533400" y="1772245"/>
             <a:ext cx="5314950" cy="2989659"/>
           </a:xfrm>
@@ -5131,11 +5163,11 @@
           <p:nvPr/>
         </p:nvPicPr>
         <p:blipFill>
-          <a:blip xmlns:r="http://schemas.openxmlformats.org/officeDocument/2006/relationships" xmlns:a="http://schemas.openxmlformats.org/drawingml/2006/main" r:embed="Rca651b0febe94822"/>
+          <a:blip xmlns:r="http://schemas.openxmlformats.org/officeDocument/2006/relationships" xmlns:a="http://schemas.openxmlformats.org/drawingml/2006/main" r:embed="Rb89682be9f9e49fb"/>
           <a:stretch xmlns:a="http://schemas.openxmlformats.org/drawingml/2006/main"/>
         </p:blipFill>
         <p:spPr>
-          <a:xfrm xmlns:a="http://schemas.openxmlformats.org/drawingml/2006/main">
+          <a:xfrm xmlns:a="http://schemas.openxmlformats.org/drawingml/2006/main" flipH="0" flipV="0">
             <a:off x="6343650" y="1772245"/>
             <a:ext cx="5314950" cy="2989659"/>
           </a:xfrm>
@@ -5198,7 +5230,7 @@
                 <a:ea typeface="Apple SD Gothic Neo"/>
                 <a:cs typeface="Apple SD Gothic Neo"/>
               </a:rPr>
-              <a:t>45 unit tests OK · Kafka/Spark integration 2/2</a:t>
+              <a:t>Producer = Consumer = Spark input · 58,036</a:t>
             </a:r>
           </a:p>
         </p:txBody>
@@ -5257,7 +5289,7 @@
                 <a:ea typeface="Apple SD Gothic Neo"/>
                 <a:cs typeface="Apple SD Gothic Neo"/>
               </a:rPr>
-              <a:t>DB 중단 중 실패 → 동일 batch 재시도 → 최종 row 1</a:t>
+              <a:t>121 bars · 58,036 records · duplicate 0</a:t>
             </a:r>
           </a:p>
         </p:txBody>
@@ -5316,7 +5348,7 @@
                 <a:ea typeface="Apple SD Gothic Neo"/>
                 <a:cs typeface="Apple SD Gothic Neo"/>
               </a:rPr>
-              <a:t>GitHub에는 API key, connection URL, 실제 원본 payload를 포함하지 않았습니다.</a:t>
+              <a:t>공개 저장소에는 재현 코드와 집계 결과만 두고, API key와 원시 payload는 제외했습니다.</a:t>
             </a:r>
           </a:p>
         </p:txBody>
@@ -5463,7 +5495,7 @@
                 <a:ea typeface="Apple SD Gothic Neo"/>
                 <a:cs typeface="Apple SD Gothic Neo"/>
               </a:rPr>
-              <a:t>이번 과제 범위는 완료했고,</a:t>
+              <a:t>이번 과제는 실제 저장까지 완료했고,</a:t>
             </a:r>
           </a:p>
           <a:p xmlns:a="http://schemas.openxmlformats.org/drawingml/2006/main">
@@ -5487,7 +5519,7 @@
                 <a:ea typeface="Apple SD Gothic Neo"/>
                 <a:cs typeface="Apple SD Gothic Neo"/>
               </a:rPr>
-              <a:t>다음은 실시간 전체 경로입니다</a:t>
+              <a:t>다음은 반복 분석 자동화입니다</a:t>
             </a:r>
           </a:p>
         </p:txBody>
@@ -5605,7 +5637,7 @@
                 <a:ea typeface="Apple SD Gothic Neo"/>
                 <a:cs typeface="Apple SD Gothic Neo"/>
               </a:rPr>
-              <a:t>실제 데이터 → Kafka → Spark → PostgreSQL 저장</a:t>
+              <a:t>NVDA records 58,036 → Kafka → Spark → 121 bars</a:t>
             </a:r>
           </a:p>
           <a:p xmlns:a="http://schemas.openxmlformats.org/drawingml/2006/main">
@@ -5629,7 +5661,7 @@
                 <a:ea typeface="Apple SD Gothic Neo"/>
                 <a:cs typeface="Apple SD Gothic Neo"/>
               </a:rPr>
-              <a:t>아키텍처·재현 명령·결과 JSON·안전한 캡처</a:t>
+              <a:t>재현 명령·결과 JSON·DB 증거 SQL</a:t>
             </a:r>
           </a:p>
         </p:txBody>
@@ -5747,7 +5779,7 @@
                 <a:ea typeface="Apple SD Gothic Neo"/>
                 <a:cs typeface="Apple SD Gothic Neo"/>
               </a:rPr>
-              <a:t>다음 정규장 WebSocket → PostgreSQL E2E</a:t>
+              <a:t>12회 CPI × 4종목 분석 범위 정제</a:t>
             </a:r>
           </a:p>
           <a:p xmlns:a="http://schemas.openxmlformats.org/drawingml/2006/main">
@@ -5771,7 +5803,7 @@
                 <a:ea typeface="Apple SD Gothic Neo"/>
                 <a:cs typeface="Apple SD Gothic Neo"/>
               </a:rPr>
-              <a:t>Airflow로 공식 경제지표 수집 → 발표 전후 영향 분석</a:t>
+              <a:t>Airflow로 수집·백필·품질 검사 자동화</a:t>
             </a:r>
           </a:p>
         </p:txBody>
@@ -5861,7 +5893,7 @@
                 <a:ea typeface="Apple SD Gothic Neo"/>
                 <a:cs typeface="Apple SD Gothic Neo"/>
               </a:rPr>
-              <a:t>피드백 요청: 현재 규모의 Spark 사용 근거와 Kafka 24시간 보관 정책이 적절한가?</a:t>
+              <a:t>피드백 요청: trade condition 정책과 Spark batch 범위를 어떻게 확장하는 것이 적절한가?</a:t>
             </a:r>
           </a:p>
         </p:txBody>

</xml_diff>

<commit_message>
docs: define cpi sip replay dataset precisely
</commit_message>
<xml_diff>
--- a/docs/presentation/us-market-pipeline-assignment.pptx
+++ b/docs/presentation/us-market-pipeline-assignment.pptx
@@ -2,19 +2,19 @@
 <file path=ppt/presentation.xml><?xml version="1.0" encoding="utf-8"?>
 <p:presentation xmlns:p="http://schemas.openxmlformats.org/presentationml/2006/main">
   <p:sldMasterIdLst>
-    <p:sldMasterId xmlns:r="http://schemas.openxmlformats.org/officeDocument/2006/relationships" id="2147483648" r:id="R1b789427a9bc4009"/>
+    <p:sldMasterId xmlns:r="http://schemas.openxmlformats.org/officeDocument/2006/relationships" id="2147483648" r:id="R9831b5f24b2d483f"/>
   </p:sldMasterIdLst>
   <p:notesMasterIdLst>
-    <p:notesMasterId xmlns:r="http://schemas.openxmlformats.org/officeDocument/2006/relationships" r:id="Ra12cab53a6904787"/>
+    <p:notesMasterId xmlns:r="http://schemas.openxmlformats.org/officeDocument/2006/relationships" r:id="R38ad874db7364ca5"/>
   </p:notesMasterIdLst>
   <p:sldIdLst>
-    <p:sldId xmlns:r="http://schemas.openxmlformats.org/officeDocument/2006/relationships" id="256" r:id="Rf3b2b3b9cfdb49bb"/>
-    <p:sldId xmlns:r="http://schemas.openxmlformats.org/officeDocument/2006/relationships" id="257" r:id="R08be589e0c674ae5"/>
-    <p:sldId xmlns:r="http://schemas.openxmlformats.org/officeDocument/2006/relationships" id="258" r:id="R7db1bf9e360a4e90"/>
-    <p:sldId xmlns:r="http://schemas.openxmlformats.org/officeDocument/2006/relationships" id="259" r:id="R560b503c58594986"/>
-    <p:sldId xmlns:r="http://schemas.openxmlformats.org/officeDocument/2006/relationships" id="260" r:id="R679b4b97d4c94f1e"/>
-    <p:sldId xmlns:r="http://schemas.openxmlformats.org/officeDocument/2006/relationships" id="261" r:id="R90806bc28d7f4092"/>
-    <p:sldId xmlns:r="http://schemas.openxmlformats.org/officeDocument/2006/relationships" id="262" r:id="R417fe89fe53648cf"/>
+    <p:sldId xmlns:r="http://schemas.openxmlformats.org/officeDocument/2006/relationships" id="256" r:id="R746aea700b2f4f02"/>
+    <p:sldId xmlns:r="http://schemas.openxmlformats.org/officeDocument/2006/relationships" id="257" r:id="Ra23b39eaca9f4c1e"/>
+    <p:sldId xmlns:r="http://schemas.openxmlformats.org/officeDocument/2006/relationships" id="258" r:id="R343d105c9f274c04"/>
+    <p:sldId xmlns:r="http://schemas.openxmlformats.org/officeDocument/2006/relationships" id="259" r:id="R440345cbc4524a56"/>
+    <p:sldId xmlns:r="http://schemas.openxmlformats.org/officeDocument/2006/relationships" id="260" r:id="R1553ade0d016472c"/>
+    <p:sldId xmlns:r="http://schemas.openxmlformats.org/officeDocument/2006/relationships" id="261" r:id="Re7aa8ca833ec4dc7"/>
+    <p:sldId xmlns:r="http://schemas.openxmlformats.org/officeDocument/2006/relationships" id="262" r:id="Rb937cfb2e8044a04"/>
   </p:sldIdLst>
   <p:sldSz cx="12192000" cy="6858000"/>
   <p:notesSz cx="6858000" cy="9144000"/>
@@ -448,7 +448,7 @@
           <a:lstStyle xmlns:a="http://schemas.openxmlformats.org/drawingml/2006/main"/>
           <a:p xmlns:a="http://schemas.openxmlformats.org/drawingml/2006/main">
             <a:r>
-              <a:t>안녕하세요. 이번 과제에서는 2026년 8월 12일 CPI 발표 전후 지정 구간에 대해 Alpaca Historical SIP Trades API가 반환한 NVDA 개별 체결 레코드 58,036건을 Kafka와 Spark로 처리해 PostgreSQL에 저장했습니다. 58,036건은 SIP 전체 시장 거래량이 아닙니다. 전체 프로젝트의 목표는 경제지표 발표 전후 시장 반응을 검증하는 것이고, 오늘은 그 데이터 처리 경로의 실제 실행 결과에 집중하겠습니다.</a:t>
+              <a:t>안녕하세요. 이번 과제의 기준 이벤트는 2026년 7월 미국 CPI이며, 2026년 8월 12일 오전 8시 30분 동부시간에 발표됐습니다. 이 시각 전후로 Alpaca Historical SIP Trades API가 반환한 NVDA 개별 체결 레코드 58,036건을 Kafka와 Spark로 처리해 PostgreSQL에 저장했습니다. 58,036건은 CPI 지표 건수나 하루치 데이터, SIP 전체 시장 거래량이 아닙니다.</a:t>
             </a:r>
           </a:p>
           <a:p xmlns:a="http://schemas.openxmlformats.org/drawingml/2006/main">
@@ -638,7 +638,7 @@
           <a:lstStyle xmlns:a="http://schemas.openxmlformats.org/drawingml/2006/main"/>
           <a:p xmlns:a="http://schemas.openxmlformats.org/drawingml/2006/main">
             <a:r>
-              <a:t>CPI 발표 시각 12시 30분 UTC를 기준으로 11시 30분 이상 13시 31분 미만의 원시 체결을 가져왔습니다. Producer, Consumer와 Spark 입력이 모두 58,036건으로 일치하고 Spark는 121개 1분봉을 저장했습니다.</a:t>
+              <a:t>CPI 발표 시각 12시 30분 UTC를 기준으로 NVDA 한 종목의 11시 30분 이상 13시 31분 미만 Historical SIP 체결 레코드를 가져왔습니다. 미국 동부시간으로는 7시 30분부터 9시 31분 직전까지이며 장전 구간과 정규장 첫 1분을 포함합니다. Producer, Consumer와 Spark 입력이 모두 58,036건으로 일치하고 Spark는 121개 1분봉을 저장했습니다.</a:t>
             </a:r>
           </a:p>
           <a:p xmlns:a="http://schemas.openxmlformats.org/drawingml/2006/main">
@@ -1111,7 +1111,7 @@
   </p:cSld>
   <p:clrMap bg1="lt1" tx1="dk1" bg2="lt2" tx2="dk2" accent1="accent1" accent2="accent2" accent3="accent3" accent4="accent4" accent5="accent5" accent6="accent6" hlink="hlink" folHlink="folHlink"/>
   <p:sldLayoutIdLst>
-    <p:sldLayoutId xmlns:r="http://schemas.openxmlformats.org/officeDocument/2006/relationships" id="2147483649" r:id="Rb8795eb59809404b"/>
+    <p:sldLayoutId xmlns:r="http://schemas.openxmlformats.org/officeDocument/2006/relationships" id="2147483649" r:id="Rb7fb785536f345dd"/>
   </p:sldLayoutIdLst>
   <p:txStyles>
     <p:titleStyle>
@@ -1912,7 +1912,7 @@
                 <a:ea typeface="Apple SD Gothic Neo"/>
                 <a:cs typeface="Apple SD Gothic Neo"/>
               </a:rPr>
-              <a:t>최종 목표: 경제지표 발표 전후 시장 반응 검증</a:t>
+              <a:t>이벤트: 2026년 7월 CPI · 2026-08-12 08:30 ET</a:t>
             </a:r>
           </a:p>
           <a:p xmlns:a="http://schemas.openxmlformats.org/drawingml/2006/main">
@@ -1936,7 +1936,7 @@
                 <a:ea typeface="Apple SD Gothic Neo"/>
                 <a:cs typeface="Apple SD Gothic Neo"/>
               </a:rPr>
-              <a:t>이번 범위: SIP raw trade → Kafka → Spark → PostgreSQL</a:t>
+              <a:t>시장 원본: NVDA Historical SIP · 07:30~09:31 ET</a:t>
             </a:r>
           </a:p>
         </p:txBody>
@@ -2042,7 +2042,7 @@
           <p:nvPr/>
         </p:nvPicPr>
         <p:blipFill>
-          <a:blip xmlns:r="http://schemas.openxmlformats.org/officeDocument/2006/relationships" xmlns:a="http://schemas.openxmlformats.org/drawingml/2006/main" r:embed="R3eeb8ee9bd5a4067"/>
+          <a:blip xmlns:r="http://schemas.openxmlformats.org/officeDocument/2006/relationships" xmlns:a="http://schemas.openxmlformats.org/drawingml/2006/main" r:embed="R7653e7574f51434c"/>
           <a:stretch xmlns:a="http://schemas.openxmlformats.org/drawingml/2006/main"/>
         </p:blipFill>
         <p:spPr>
@@ -2806,7 +2806,7 @@
                 <a:ea typeface="Apple SD Gothic Neo"/>
                 <a:cs typeface="Apple SD Gothic Neo"/>
               </a:rPr>
-              <a:t>• NVDA · 11:30~13:31 UTC</a:t>
+              <a:t>• 2026-08-12 · NVDA · feed=sip</a:t>
             </a:r>
           </a:p>
           <a:p xmlns:a="http://schemas.openxmlformats.org/drawingml/2006/main">
@@ -2830,7 +2830,7 @@
                 <a:ea typeface="Apple SD Gothic Neo"/>
                 <a:cs typeface="Apple SD Gothic Neo"/>
               </a:rPr>
-              <a:t>• API 체결 레코드 58,036건</a:t>
+              <a:t>• 07:30~09:31 ET 체결 레코드 58,036건</a:t>
             </a:r>
           </a:p>
           <a:p xmlns:a="http://schemas.openxmlformats.org/drawingml/2006/main">
@@ -2956,7 +2956,7 @@
           <p:nvPr/>
         </p:nvPicPr>
         <p:blipFill>
-          <a:blip xmlns:r="http://schemas.openxmlformats.org/officeDocument/2006/relationships" xmlns:a="http://schemas.openxmlformats.org/drawingml/2006/main" r:embed="R73d60b7221b24506"/>
+          <a:blip xmlns:r="http://schemas.openxmlformats.org/officeDocument/2006/relationships" xmlns:a="http://schemas.openxmlformats.org/drawingml/2006/main" r:embed="Rff931fa0962d46f4"/>
           <a:stretch xmlns:a="http://schemas.openxmlformats.org/drawingml/2006/main"/>
         </p:blipFill>
         <p:spPr>
@@ -5141,7 +5141,7 @@
           <p:nvPr/>
         </p:nvPicPr>
         <p:blipFill>
-          <a:blip xmlns:r="http://schemas.openxmlformats.org/officeDocument/2006/relationships" xmlns:a="http://schemas.openxmlformats.org/drawingml/2006/main" r:embed="R0b6fa035c6034309"/>
+          <a:blip xmlns:r="http://schemas.openxmlformats.org/officeDocument/2006/relationships" xmlns:a="http://schemas.openxmlformats.org/drawingml/2006/main" r:embed="Rf7bdf5cfc5e04582"/>
           <a:stretch xmlns:a="http://schemas.openxmlformats.org/drawingml/2006/main"/>
         </p:blipFill>
         <p:spPr>
@@ -5163,7 +5163,7 @@
           <p:nvPr/>
         </p:nvPicPr>
         <p:blipFill>
-          <a:blip xmlns:r="http://schemas.openxmlformats.org/officeDocument/2006/relationships" xmlns:a="http://schemas.openxmlformats.org/drawingml/2006/main" r:embed="Rb89682be9f9e49fb"/>
+          <a:blip xmlns:r="http://schemas.openxmlformats.org/officeDocument/2006/relationships" xmlns:a="http://schemas.openxmlformats.org/drawingml/2006/main" r:embed="Rc66667e86ff34016"/>
           <a:stretch xmlns:a="http://schemas.openxmlformats.org/drawingml/2006/main"/>
         </p:blipFill>
         <p:spPr>

</xml_diff>

<commit_message>
docs: define provider bar trade count precisely
</commit_message>
<xml_diff>
--- a/docs/presentation/us-market-pipeline-assignment.pptx
+++ b/docs/presentation/us-market-pipeline-assignment.pptx
@@ -2,19 +2,19 @@
 <file path=ppt/presentation.xml><?xml version="1.0" encoding="utf-8"?>
 <p:presentation xmlns:p="http://schemas.openxmlformats.org/presentationml/2006/main">
   <p:sldMasterIdLst>
-    <p:sldMasterId xmlns:r="http://schemas.openxmlformats.org/officeDocument/2006/relationships" id="2147483648" r:id="R9831b5f24b2d483f"/>
+    <p:sldMasterId xmlns:r="http://schemas.openxmlformats.org/officeDocument/2006/relationships" id="2147483648" r:id="R659c160ff3eb4248"/>
   </p:sldMasterIdLst>
   <p:notesMasterIdLst>
-    <p:notesMasterId xmlns:r="http://schemas.openxmlformats.org/officeDocument/2006/relationships" r:id="R38ad874db7364ca5"/>
+    <p:notesMasterId xmlns:r="http://schemas.openxmlformats.org/officeDocument/2006/relationships" r:id="Rf2c0bc1daeb74ac6"/>
   </p:notesMasterIdLst>
   <p:sldIdLst>
-    <p:sldId xmlns:r="http://schemas.openxmlformats.org/officeDocument/2006/relationships" id="256" r:id="R746aea700b2f4f02"/>
-    <p:sldId xmlns:r="http://schemas.openxmlformats.org/officeDocument/2006/relationships" id="257" r:id="Ra23b39eaca9f4c1e"/>
-    <p:sldId xmlns:r="http://schemas.openxmlformats.org/officeDocument/2006/relationships" id="258" r:id="R343d105c9f274c04"/>
-    <p:sldId xmlns:r="http://schemas.openxmlformats.org/officeDocument/2006/relationships" id="259" r:id="R440345cbc4524a56"/>
-    <p:sldId xmlns:r="http://schemas.openxmlformats.org/officeDocument/2006/relationships" id="260" r:id="R1553ade0d016472c"/>
-    <p:sldId xmlns:r="http://schemas.openxmlformats.org/officeDocument/2006/relationships" id="261" r:id="Re7aa8ca833ec4dc7"/>
-    <p:sldId xmlns:r="http://schemas.openxmlformats.org/officeDocument/2006/relationships" id="262" r:id="Rb937cfb2e8044a04"/>
+    <p:sldId xmlns:r="http://schemas.openxmlformats.org/officeDocument/2006/relationships" id="256" r:id="R71f490366a4840c1"/>
+    <p:sldId xmlns:r="http://schemas.openxmlformats.org/officeDocument/2006/relationships" id="257" r:id="R61a836453ad24ce7"/>
+    <p:sldId xmlns:r="http://schemas.openxmlformats.org/officeDocument/2006/relationships" id="258" r:id="R2b6e7ace16bd49b6"/>
+    <p:sldId xmlns:r="http://schemas.openxmlformats.org/officeDocument/2006/relationships" id="259" r:id="Ra1fffb72113a4bde"/>
+    <p:sldId xmlns:r="http://schemas.openxmlformats.org/officeDocument/2006/relationships" id="260" r:id="Rbca7b1ef3896465e"/>
+    <p:sldId xmlns:r="http://schemas.openxmlformats.org/officeDocument/2006/relationships" id="261" r:id="R3a564beefc3f4a8e"/>
+    <p:sldId xmlns:r="http://schemas.openxmlformats.org/officeDocument/2006/relationships" id="262" r:id="Rcca4ef2ccc074d3c"/>
   </p:sldIdLst>
   <p:sldSz cx="12192000" cy="6858000"/>
   <p:notesSz cx="6858000" cy="9144000"/>
@@ -1111,7 +1111,7 @@
   </p:cSld>
   <p:clrMap bg1="lt1" tx1="dk1" bg2="lt2" tx2="dk2" accent1="accent1" accent2="accent2" accent3="accent3" accent4="accent4" accent5="accent5" accent6="accent6" hlink="hlink" folHlink="folHlink"/>
   <p:sldLayoutIdLst>
-    <p:sldLayoutId xmlns:r="http://schemas.openxmlformats.org/officeDocument/2006/relationships" id="2147483649" r:id="Rb7fb785536f345dd"/>
+    <p:sldLayoutId xmlns:r="http://schemas.openxmlformats.org/officeDocument/2006/relationships" id="2147483649" r:id="Rfc6c0e9b6d374fbc"/>
   </p:sldLayoutIdLst>
   <p:txStyles>
     <p:titleStyle>
@@ -2042,7 +2042,7 @@
           <p:nvPr/>
         </p:nvPicPr>
         <p:blipFill>
-          <a:blip xmlns:r="http://schemas.openxmlformats.org/officeDocument/2006/relationships" xmlns:a="http://schemas.openxmlformats.org/drawingml/2006/main" r:embed="R7653e7574f51434c"/>
+          <a:blip xmlns:r="http://schemas.openxmlformats.org/officeDocument/2006/relationships" xmlns:a="http://schemas.openxmlformats.org/drawingml/2006/main" r:embed="Red59a314e2814e60"/>
           <a:stretch xmlns:a="http://schemas.openxmlformats.org/drawingml/2006/main"/>
         </p:blipFill>
         <p:spPr>
@@ -2956,7 +2956,7 @@
           <p:nvPr/>
         </p:nvPicPr>
         <p:blipFill>
-          <a:blip xmlns:r="http://schemas.openxmlformats.org/officeDocument/2006/relationships" xmlns:a="http://schemas.openxmlformats.org/drawingml/2006/main" r:embed="Rff931fa0962d46f4"/>
+          <a:blip xmlns:r="http://schemas.openxmlformats.org/officeDocument/2006/relationships" xmlns:a="http://schemas.openxmlformats.org/drawingml/2006/main" r:embed="R5d6d8b29241842b8"/>
           <a:stretch xmlns:a="http://schemas.openxmlformats.org/drawingml/2006/main"/>
         </p:blipFill>
         <p:spPr>
@@ -4890,7 +4890,7 @@
                 <a:ea typeface="Apple SD Gothic Neo"/>
                 <a:cs typeface="Apple SD Gothic Neo"/>
               </a:rPr>
-              <a:t>provider bar trade_count 58,034건과 raw replay 58,036건은 별도 source로 보존했습니다.</a:t>
+              <a:t>58,034 = 2026-08-12 NVDA SIP 1분봉 121개의 trade_count 합계 · 07:30–09:31 ET (raw 행 58,036)</a:t>
             </a:r>
           </a:p>
         </p:txBody>
@@ -5141,7 +5141,7 @@
           <p:nvPr/>
         </p:nvPicPr>
         <p:blipFill>
-          <a:blip xmlns:r="http://schemas.openxmlformats.org/officeDocument/2006/relationships" xmlns:a="http://schemas.openxmlformats.org/drawingml/2006/main" r:embed="Rf7bdf5cfc5e04582"/>
+          <a:blip xmlns:r="http://schemas.openxmlformats.org/officeDocument/2006/relationships" xmlns:a="http://schemas.openxmlformats.org/drawingml/2006/main" r:embed="Rfe338558f4d14b36"/>
           <a:stretch xmlns:a="http://schemas.openxmlformats.org/drawingml/2006/main"/>
         </p:blipFill>
         <p:spPr>
@@ -5163,7 +5163,7 @@
           <p:nvPr/>
         </p:nvPicPr>
         <p:blipFill>
-          <a:blip xmlns:r="http://schemas.openxmlformats.org/officeDocument/2006/relationships" xmlns:a="http://schemas.openxmlformats.org/drawingml/2006/main" r:embed="Rc66667e86ff34016"/>
+          <a:blip xmlns:r="http://schemas.openxmlformats.org/officeDocument/2006/relationships" xmlns:a="http://schemas.openxmlformats.org/drawingml/2006/main" r:embed="R90d117778c074c1a"/>
           <a:stretch xmlns:a="http://schemas.openxmlformats.org/drawingml/2006/main"/>
         </p:blipFill>
         <p:spPr>

</xml_diff>